<commit_message>
docs: align final slides with enterprise security feedback
</commit_message>
<xml_diff>
--- a/AURA/submission/AURA_5_SLIDES_FINAL.pptx
+++ b/AURA/submission/AURA_5_SLIDES_FINAL.pptx
@@ -2,17 +2,17 @@
 <file path=ppt/presentation.xml><?xml version="1.0" encoding="utf-8"?>
 <p:presentation xmlns:p="http://schemas.openxmlformats.org/presentationml/2006/main">
   <p:sldMasterIdLst>
-    <p:sldMasterId xmlns:r="http://schemas.openxmlformats.org/officeDocument/2006/relationships" id="2147483648" r:id="Ra1953dc87b8043ff"/>
+    <p:sldMasterId xmlns:r="http://schemas.openxmlformats.org/officeDocument/2006/relationships" id="2147483648" r:id="Re3e690867ddd42e3"/>
   </p:sldMasterIdLst>
   <p:notesMasterIdLst>
-    <p:notesMasterId xmlns:r="http://schemas.openxmlformats.org/officeDocument/2006/relationships" r:id="R2d1dbfac85fa436f"/>
+    <p:notesMasterId xmlns:r="http://schemas.openxmlformats.org/officeDocument/2006/relationships" r:id="Rdd8bde2581c744e7"/>
   </p:notesMasterIdLst>
   <p:sldIdLst>
-    <p:sldId xmlns:r="http://schemas.openxmlformats.org/officeDocument/2006/relationships" id="256" r:id="Refd55929fba44c91"/>
-    <p:sldId xmlns:r="http://schemas.openxmlformats.org/officeDocument/2006/relationships" id="257" r:id="R6ab89377d6854b9c"/>
-    <p:sldId xmlns:r="http://schemas.openxmlformats.org/officeDocument/2006/relationships" id="258" r:id="Rd18720bc99ff4f82"/>
-    <p:sldId xmlns:r="http://schemas.openxmlformats.org/officeDocument/2006/relationships" id="259" r:id="Rfb107deeac364798"/>
-    <p:sldId xmlns:r="http://schemas.openxmlformats.org/officeDocument/2006/relationships" id="260" r:id="Rdd7f74eb3e5a4f82"/>
+    <p:sldId xmlns:r="http://schemas.openxmlformats.org/officeDocument/2006/relationships" id="256" r:id="Re9bcf8f27eab4878"/>
+    <p:sldId xmlns:r="http://schemas.openxmlformats.org/officeDocument/2006/relationships" id="257" r:id="R7f8084d9ca524272"/>
+    <p:sldId xmlns:r="http://schemas.openxmlformats.org/officeDocument/2006/relationships" id="258" r:id="R46fd3211fff54cb1"/>
+    <p:sldId xmlns:r="http://schemas.openxmlformats.org/officeDocument/2006/relationships" id="259" r:id="R570cf26866f94c1c"/>
+    <p:sldId xmlns:r="http://schemas.openxmlformats.org/officeDocument/2006/relationships" id="260" r:id="R269ab995fdaa4197"/>
   </p:sldIdLst>
   <p:sldSz cx="12192000" cy="6858000"/>
   <p:notesSz cx="6858000" cy="9144000"/>
@@ -816,7 +816,7 @@
           <a:lstStyle xmlns:a="http://schemas.openxmlformats.org/drawingml/2006/main"/>
           <a:p xmlns:a="http://schemas.openxmlformats.org/drawingml/2006/main">
             <a:r>
-              <a:t>MỞ: Slide này phân định trực tiếp thành phần chạy thật với dữ liệu và prototype mô phỏng.</a:t>
+              <a:t>MỞ: Slide này phân định trực tiếp thành phần chạy thật, quyền của model và phần còn mô phỏng.</a:t>
             </a:r>
           </a:p>
           <a:p xmlns:a="http://schemas.openxmlformats.org/drawingml/2006/main">
@@ -826,7 +826,7 @@
           </a:p>
           <a:p xmlns:a="http://schemas.openxmlformats.org/drawingml/2006/main">
             <a:r>
-              <a:t>Bốn lớp chạy thật gồm giao diện Razor MVC, queue/worker trong SQL, AI adapter cùng evidence contract, và PolicyDecisionEngine C# với dữ liệu bền vững. Model có thể thay, nhưng mọi facts vẫn phải qua contract, semantic gate và cùng policy engine.</a:t>
+              <a:t>Ranh giới thực thi có tính quyết định là: model chỉ nhận ảnh và trả DTO theo contract; model không có tool, không có credential ghi database và không tự sửa trạng thái. Semantic validator kiểm tra facts, còn PolicyDecisionEngine C# mới chọn route. Vì vậy đổi model không đồng nghĩa đổi policy.</a:t>
             </a:r>
           </a:p>
           <a:p xmlns:a="http://schemas.openxmlformats.org/drawingml/2006/main">
@@ -836,7 +836,7 @@
           </a:p>
           <a:p xmlns:a="http://schemas.openxmlformats.org/drawingml/2006/main">
             <a:r>
-              <a:t>Ba khối mô phỏng hoặc test là 30 ảnh tổng hợp, 5 fixture Verify và evidence overlay prototype. Overlay hiện chỉ gắn với hash, chưa nối vào extraction hoặc policy và chưa có benchmark localization trên ảnh unseen.</a:t>
+              <a:t>Identity hiện mới là metadata demo gồm mã nhân viên, tên và phòng ban; đó chưa phải danh tính đã xác thực. Các vai trò người gửi, nhân viên và quản lý mới là vai trò workflow, chưa phải production RBAC hay least-privilege enforcement.</a:t>
             </a:r>
           </a:p>
           <a:p xmlns:a="http://schemas.openxmlformats.org/drawingml/2006/main">
@@ -846,7 +846,7 @@
           </a:p>
           <a:p xmlns:a="http://schemas.openxmlformats.org/drawingml/2006/main">
             <a:r>
-              <a:t>Mô hình triển khai hiện tại là localhost, một process; AI gọi qua OpenRouter tới route Alibaba; fallback Ollama mặc định tắt.</a:t>
+              <a:t>Upload hiện đã kiểm extension, MIME, magic bytes, giới hạn 5 MB và lưu riêng tư; model không được cấp quyền hệ thống. Tuy nhiên đây mới là logical isolation, chưa phải sandbox OS hoặc container cho file parser.</a:t>
             </a:r>
           </a:p>
           <a:p xmlns:a="http://schemas.openxmlformats.org/drawingml/2006/main">
@@ -856,7 +856,7 @@
           </a:p>
           <a:p xmlns:a="http://schemas.openxmlformats.org/drawingml/2006/main">
             <a:r>
-              <a:t>Nguồn: submission/AURA_WORKFLOW_SPEC.md; docs/EVALUATION_EVIDENCE.md; docs/RUNBOOK.md; docs/CURRENT_PROJECT_STATUS.md.</a:t>
+              <a:t>Ba khối mô phỏng hoặc test là 30 ảnh tổng hợp, 5 fixture Verify và evidence overlay prototype. Overlay chỉ gắn với hash, chưa nối extraction hoặc policy và chưa có benchmark localization trên ảnh unseen.</a:t>
             </a:r>
           </a:p>
           <a:p xmlns:a="http://schemas.openxmlformats.org/drawingml/2006/main">
@@ -866,7 +866,27 @@
           </a:p>
           <a:p xmlns:a="http://schemas.openxmlformats.org/drawingml/2006/main">
             <a:r>
-              <a:t>CHUYỂN: Kiến trúc đã xác định rõ phạm vi; slide cuối nêu lỗi đã quan sát và điều kiện để mở rộng an toàn.</a:t>
+              <a:t>Mô hình hiện tại là localhost, một process; AI gọi qua OpenRouter tới route Alibaba; fallback Ollama tắt.</a:t>
+            </a:r>
+          </a:p>
+          <a:p xmlns:a="http://schemas.openxmlformats.org/drawingml/2006/main">
+            <a:r>
+              <a:t/>
+            </a:r>
+          </a:p>
+          <a:p xmlns:a="http://schemas.openxmlformats.org/drawingml/2006/main">
+            <a:r>
+              <a:t>Nguồn: submission/AURA_WORKFLOW_SPEC.md; submission/AURA_PROPOSAL_VI.md; docs/CURRENT_PROJECT_STATUS.md; src/AURA/Infrastructure/AI/ReceiptExtractionContract.cs; src/AURA/Core/Policy/PolicyDecisionEngine.cs.</a:t>
+            </a:r>
+          </a:p>
+          <a:p xmlns:a="http://schemas.openxmlformats.org/drawingml/2006/main">
+            <a:r>
+              <a:t/>
+            </a:r>
+          </a:p>
+          <a:p xmlns:a="http://schemas.openxmlformats.org/drawingml/2006/main">
+            <a:r>
+              <a:t>CHUYỂN: Slide cuối biến khoảng cách từ demo tới production thành các security gate có thể kiểm chứng.</a:t>
             </a:r>
           </a:p>
         </p:txBody>
@@ -936,7 +956,7 @@
           <a:lstStyle xmlns:a="http://schemas.openxmlformats.org/drawingml/2006/main"/>
           <a:p xmlns:a="http://schemas.openxmlformats.org/drawingml/2006/main">
             <a:r>
-              <a:t>MỞ: Slide cuối tách ba phần: lỗi đã quan sát, hạn chế còn lại và điều kiện xác nhận cho bước tiếp theo.</a:t>
+              <a:t>MỞ: Slide cuối tách ba phần: lỗi đã quan sát, hạn chế còn lại và security gate trước khi đưa demo vào production.</a:t>
             </a:r>
           </a:p>
           <a:p xmlns:a="http://schemas.openxmlformats.org/drawingml/2006/main">
@@ -976,7 +996,7 @@
           </a:p>
           <a:p xmlns:a="http://schemas.openxmlformats.org/drawingml/2006/main">
             <a:r>
-              <a:t>Lộ trình có gate cụ thể: user study có consent và feedback tiêu cực; distributed coordination trước multi-instance; PDF/object storage qua kiểm MIME, AV và retrieval; RBAC qua authorization test; overlay qua localization QA trên receipt unseen.</a:t>
+              <a:t>Từ demo tới production, identity phải chuyển từ metadata sang OIDC hoặc SSO và service identity. Least privilege cần role matrix deny-by-default cho người gửi, reviewer, manager và operator, kèm authorization tests và audit.</a:t>
             </a:r>
           </a:p>
           <a:p xmlns:a="http://schemas.openxmlformats.org/drawingml/2006/main">
@@ -986,7 +1006,7 @@
           </a:p>
           <a:p xmlns:a="http://schemas.openxmlformats.org/drawingml/2006/main">
             <a:r>
-              <a:t>Nguồn: docs/EVALUATION_EVIDENCE.md; D:/aura/demo_evidence/22_NewRealReceipt_ForHoldout/holdout10_evidence_v3_2026-10-13/09_documentation_update/mismatch-register.corrected-utf8.json; D:/aura/demo_evidence/22_NewRealReceipt_ForHoldout/regression12_original_bytes_v1_2026-10-13/07_analysis/REGRESSION12_ORIGINAL_BYTES_RESULT_2026-10-13.md.</a:t>
+              <a:t>Sandbox hiện mới ở mức logical: model không có tool hay quyền ghi DB trực tiếp. Production cần quarantine, AV hoặc CDR, parser cô lập với quyền thấp, cùng giới hạn CPU, RAM, thời gian và network egress.</a:t>
             </a:r>
           </a:p>
           <a:p xmlns:a="http://schemas.openxmlformats.org/drawingml/2006/main">
@@ -996,7 +1016,27 @@
           </a:p>
           <a:p xmlns:a="http://schemas.openxmlformats.org/drawingml/2006/main">
             <a:r>
-              <a:t>KẾT: AURA hiện phù hợp cho demo có giám sát. Bước tiếp theo chỉ được coi là đạt khi qua gate đã định trước.</a:t>
+              <a:t>Scale vẫn cần distributed limiter, cooldown, circuit và lock trước multi-instance; user study vẫn PENDING và feedback chung của doanh nghiệp không thay thế record từ ba người dùng.</a:t>
+            </a:r>
+          </a:p>
+          <a:p xmlns:a="http://schemas.openxmlformats.org/drawingml/2006/main">
+            <a:r>
+              <a:t/>
+            </a:r>
+          </a:p>
+          <a:p xmlns:a="http://schemas.openxmlformats.org/drawingml/2006/main">
+            <a:r>
+              <a:t>Nguồn: docs/EVALUATION_EVIDENCE.md; docs/CURRENT_PROJECT_STATUS.md; submission/AURA_WORKFLOW_SPEC.md; submission/AURA_PROPOSAL_VI.md.</a:t>
+            </a:r>
+          </a:p>
+          <a:p xmlns:a="http://schemas.openxmlformats.org/drawingml/2006/main">
+            <a:r>
+              <a:t/>
+            </a:r>
+          </a:p>
+          <a:p xmlns:a="http://schemas.openxmlformats.org/drawingml/2006/main">
+            <a:r>
+              <a:t>KẾT: AURA là supervised MVP có ranh giới quyết định rõ, chưa tự nhận production-ready. Chỉ mở rộng khi từng security gate đạt bằng test và audit evidence.</a:t>
             </a:r>
           </a:p>
         </p:txBody>
@@ -1043,7 +1083,7 @@
           <p:cNvPr id="3" name="Title">
             <a:extLst xmlns:a="http://schemas.openxmlformats.org/drawingml/2006/main">
               <a:ext uri="{FF2B5EF4-FFF2-40B4-BE49-F238E27FC236}">
-                <a16:creationId xmlns:a16="http://schemas.microsoft.com/office/drawing/2014/main" id="{0DAE1761-9709-4151-B407-E59E317F3CA5}"/>
+                <a16:creationId xmlns:a16="http://schemas.microsoft.com/office/drawing/2014/main" id="{59D4D120-B5CE-4CD9-A949-B70AE517DCDD}"/>
               </a:ext>
             </a:extLst>
           </p:cNvPr>
@@ -1200,7 +1240,7 @@
           <p:cNvPr id="2" name="Subtitle">
             <a:extLst xmlns:a="http://schemas.openxmlformats.org/drawingml/2006/main">
               <a:ext uri="{FF2B5EF4-FFF2-40B4-BE49-F238E27FC236}">
-                <a16:creationId xmlns:a16="http://schemas.microsoft.com/office/drawing/2014/main" id="{CCBB1FE8-CBDC-4C55-9927-7CAFC124AF41}"/>
+                <a16:creationId xmlns:a16="http://schemas.microsoft.com/office/drawing/2014/main" id="{C264447C-C728-4370-9252-53F4D6511963}"/>
               </a:ext>
             </a:extLst>
           </p:cNvPr>
@@ -1374,7 +1414,7 @@
           <p:cNvPr id="4" name="Layout_Divider">
             <a:extLst xmlns:a="http://schemas.openxmlformats.org/drawingml/2006/main">
               <a:ext uri="{FF2B5EF4-FFF2-40B4-BE49-F238E27FC236}">
-                <a16:creationId xmlns:a16="http://schemas.microsoft.com/office/drawing/2014/main" id="{BE52DA63-5E49-4D96-BA22-734871AE8A34}"/>
+                <a16:creationId xmlns:a16="http://schemas.microsoft.com/office/drawing/2014/main" id="{38D12414-7062-4192-8828-FC07DB947BA7}"/>
               </a:ext>
             </a:extLst>
           </p:cNvPr>
@@ -1405,7 +1445,7 @@
           <p:cNvPr id="2" name="Layout_Footer">
             <a:extLst xmlns:a="http://schemas.openxmlformats.org/drawingml/2006/main">
               <a:ext uri="{FF2B5EF4-FFF2-40B4-BE49-F238E27FC236}">
-                <a16:creationId xmlns:a16="http://schemas.microsoft.com/office/drawing/2014/main" id="{ECE094AF-5045-4D65-8EC5-9890E24DD7EC}"/>
+                <a16:creationId xmlns:a16="http://schemas.microsoft.com/office/drawing/2014/main" id="{FC51FADC-82BF-4011-AED0-11CDCBB25D42}"/>
               </a:ext>
             </a:extLst>
           </p:cNvPr>
@@ -1473,7 +1513,7 @@
           <p:cNvPr id="3" name="Layout_PageNumber">
             <a:extLst xmlns:a="http://schemas.openxmlformats.org/drawingml/2006/main">
               <a:ext uri="{FF2B5EF4-FFF2-40B4-BE49-F238E27FC236}">
-                <a16:creationId xmlns:a16="http://schemas.microsoft.com/office/drawing/2014/main" id="{0706B44C-8E78-46C0-8DE0-57F8A55DE069}"/>
+                <a16:creationId xmlns:a16="http://schemas.microsoft.com/office/drawing/2014/main" id="{108E5530-A29B-426A-BAE7-A3924003A222}"/>
               </a:ext>
             </a:extLst>
           </p:cNvPr>
@@ -1558,7 +1598,7 @@
           <p:cNvPr id="5" name="Layout_Divider">
             <a:extLst xmlns:a="http://schemas.openxmlformats.org/drawingml/2006/main">
               <a:ext uri="{FF2B5EF4-FFF2-40B4-BE49-F238E27FC236}">
-                <a16:creationId xmlns:a16="http://schemas.microsoft.com/office/drawing/2014/main" id="{42EA3086-B8A6-4C2C-AF21-876E6F2A620D}"/>
+                <a16:creationId xmlns:a16="http://schemas.microsoft.com/office/drawing/2014/main" id="{286F9842-B753-4413-84D6-8966E575B314}"/>
               </a:ext>
             </a:extLst>
           </p:cNvPr>
@@ -1589,7 +1629,7 @@
           <p:cNvPr id="2" name="Layout_Footer">
             <a:extLst xmlns:a="http://schemas.openxmlformats.org/drawingml/2006/main">
               <a:ext uri="{FF2B5EF4-FFF2-40B4-BE49-F238E27FC236}">
-                <a16:creationId xmlns:a16="http://schemas.microsoft.com/office/drawing/2014/main" id="{78CEC9BA-52F0-4B0C-B485-9D3459C74050}"/>
+                <a16:creationId xmlns:a16="http://schemas.microsoft.com/office/drawing/2014/main" id="{13DF480E-358A-43ED-A04B-5F2095E78E99}"/>
               </a:ext>
             </a:extLst>
           </p:cNvPr>
@@ -1657,7 +1697,7 @@
           <p:cNvPr id="3" name="Layout_LimitFooter">
             <a:extLst xmlns:a="http://schemas.openxmlformats.org/drawingml/2006/main">
               <a:ext uri="{FF2B5EF4-FFF2-40B4-BE49-F238E27FC236}">
-                <a16:creationId xmlns:a16="http://schemas.microsoft.com/office/drawing/2014/main" id="{C0E3F266-1011-494B-9F9D-18527161B7AD}"/>
+                <a16:creationId xmlns:a16="http://schemas.microsoft.com/office/drawing/2014/main" id="{3906E5B5-013E-42CC-A35E-27553A17916C}"/>
               </a:ext>
             </a:extLst>
           </p:cNvPr>
@@ -1725,7 +1765,7 @@
           <p:cNvPr id="4" name="Layout_PageNumber">
             <a:extLst xmlns:a="http://schemas.openxmlformats.org/drawingml/2006/main">
               <a:ext uri="{FF2B5EF4-FFF2-40B4-BE49-F238E27FC236}">
-                <a16:creationId xmlns:a16="http://schemas.microsoft.com/office/drawing/2014/main" id="{AD10FD8F-256F-471D-B060-86944AE666FA}"/>
+                <a16:creationId xmlns:a16="http://schemas.microsoft.com/office/drawing/2014/main" id="{90D24A90-ED99-4354-B0E4-0F9F9E5D5CCE}"/>
               </a:ext>
             </a:extLst>
           </p:cNvPr>
@@ -1810,7 +1850,7 @@
           <p:cNvPr id="2" name="Section title">
             <a:extLst xmlns:a="http://schemas.openxmlformats.org/drawingml/2006/main">
               <a:ext uri="{FF2B5EF4-FFF2-40B4-BE49-F238E27FC236}">
-                <a16:creationId xmlns:a16="http://schemas.microsoft.com/office/drawing/2014/main" id="{F5857801-F4B1-4991-A2C3-576B68A3556B}"/>
+                <a16:creationId xmlns:a16="http://schemas.microsoft.com/office/drawing/2014/main" id="{1A9665DA-1C28-460A-B08F-25EF3FEF0296}"/>
               </a:ext>
             </a:extLst>
           </p:cNvPr>
@@ -1984,7 +2024,7 @@
           <p:cNvPr id="3" name="Title">
             <a:extLst xmlns:a="http://schemas.openxmlformats.org/drawingml/2006/main">
               <a:ext uri="{FF2B5EF4-FFF2-40B4-BE49-F238E27FC236}">
-                <a16:creationId xmlns:a16="http://schemas.microsoft.com/office/drawing/2014/main" id="{CC98FA0D-F6AF-421E-BD89-3E0301AC50A6}"/>
+                <a16:creationId xmlns:a16="http://schemas.microsoft.com/office/drawing/2014/main" id="{CEECA98A-BE84-4C9F-AAC7-A7BDBA036838}"/>
               </a:ext>
             </a:extLst>
           </p:cNvPr>
@@ -2141,7 +2181,7 @@
           <p:cNvPr id="2" name="Body">
             <a:extLst xmlns:a="http://schemas.openxmlformats.org/drawingml/2006/main">
               <a:ext uri="{FF2B5EF4-FFF2-40B4-BE49-F238E27FC236}">
-                <a16:creationId xmlns:a16="http://schemas.microsoft.com/office/drawing/2014/main" id="{0588C912-AB44-4044-9037-7EA1F48A0205}"/>
+                <a16:creationId xmlns:a16="http://schemas.microsoft.com/office/drawing/2014/main" id="{5B6E3F40-B814-4EC3-A252-A1B2CDE3BA5D}"/>
               </a:ext>
             </a:extLst>
           </p:cNvPr>
@@ -2315,7 +2355,7 @@
           <p:cNvPr id="4" name="Title">
             <a:extLst xmlns:a="http://schemas.openxmlformats.org/drawingml/2006/main">
               <a:ext uri="{FF2B5EF4-FFF2-40B4-BE49-F238E27FC236}">
-                <a16:creationId xmlns:a16="http://schemas.microsoft.com/office/drawing/2014/main" id="{3FDE0976-0154-42C3-8925-F9F2B46542BB}"/>
+                <a16:creationId xmlns:a16="http://schemas.microsoft.com/office/drawing/2014/main" id="{8E79C47E-03F9-4D9B-B611-82D5622235AD}"/>
               </a:ext>
             </a:extLst>
           </p:cNvPr>
@@ -2472,7 +2512,7 @@
           <p:cNvPr id="2" name="Left column">
             <a:extLst xmlns:a="http://schemas.openxmlformats.org/drawingml/2006/main">
               <a:ext uri="{FF2B5EF4-FFF2-40B4-BE49-F238E27FC236}">
-                <a16:creationId xmlns:a16="http://schemas.microsoft.com/office/drawing/2014/main" id="{10209360-711E-4486-8BF1-2305DB2E3832}"/>
+                <a16:creationId xmlns:a16="http://schemas.microsoft.com/office/drawing/2014/main" id="{27907B6D-F285-4EC0-9EFD-F9CB241C2A5C}"/>
               </a:ext>
             </a:extLst>
           </p:cNvPr>
@@ -2629,7 +2669,7 @@
           <p:cNvPr id="3" name="Right column">
             <a:extLst xmlns:a="http://schemas.openxmlformats.org/drawingml/2006/main">
               <a:ext uri="{FF2B5EF4-FFF2-40B4-BE49-F238E27FC236}">
-                <a16:creationId xmlns:a16="http://schemas.microsoft.com/office/drawing/2014/main" id="{4A48292F-A8AF-4A6F-A8ED-460E01A76237}"/>
+                <a16:creationId xmlns:a16="http://schemas.microsoft.com/office/drawing/2014/main" id="{62DE60A6-656C-4EFD-8617-69CFB0D98404}"/>
               </a:ext>
             </a:extLst>
           </p:cNvPr>
@@ -2803,7 +2843,7 @@
           <p:cNvPr id="3" name="Title">
             <a:extLst xmlns:a="http://schemas.openxmlformats.org/drawingml/2006/main">
               <a:ext uri="{FF2B5EF4-FFF2-40B4-BE49-F238E27FC236}">
-                <a16:creationId xmlns:a16="http://schemas.microsoft.com/office/drawing/2014/main" id="{69DE589A-3411-4CC4-9B81-062CC55FEF63}"/>
+                <a16:creationId xmlns:a16="http://schemas.microsoft.com/office/drawing/2014/main" id="{EF1B1603-308C-4E25-9607-A01E13686E69}"/>
               </a:ext>
             </a:extLst>
           </p:cNvPr>
@@ -2960,7 +3000,7 @@
           <p:cNvPr id="2" name="Left column">
             <a:extLst xmlns:a="http://schemas.openxmlformats.org/drawingml/2006/main">
               <a:ext uri="{FF2B5EF4-FFF2-40B4-BE49-F238E27FC236}">
-                <a16:creationId xmlns:a16="http://schemas.microsoft.com/office/drawing/2014/main" id="{91E8EF3D-11C7-4DA1-AE22-A0B2CC3EDC88}"/>
+                <a16:creationId xmlns:a16="http://schemas.microsoft.com/office/drawing/2014/main" id="{877754D3-A070-4B52-BEA7-E1B3F0506C0C}"/>
               </a:ext>
             </a:extLst>
           </p:cNvPr>
@@ -3151,7 +3191,7 @@
           <p:cNvPr id="4" name="Layout_Divider">
             <a:extLst xmlns:a="http://schemas.openxmlformats.org/drawingml/2006/main">
               <a:ext uri="{FF2B5EF4-FFF2-40B4-BE49-F238E27FC236}">
-                <a16:creationId xmlns:a16="http://schemas.microsoft.com/office/drawing/2014/main" id="{232D4D0D-3FD2-424C-ADE0-9DA0A8D10629}"/>
+                <a16:creationId xmlns:a16="http://schemas.microsoft.com/office/drawing/2014/main" id="{6336E98D-70AF-4183-A9C9-1E5EEB862D1B}"/>
               </a:ext>
             </a:extLst>
           </p:cNvPr>
@@ -3182,7 +3222,7 @@
           <p:cNvPr id="2" name="Layout_Footer">
             <a:extLst xmlns:a="http://schemas.openxmlformats.org/drawingml/2006/main">
               <a:ext uri="{FF2B5EF4-FFF2-40B4-BE49-F238E27FC236}">
-                <a16:creationId xmlns:a16="http://schemas.microsoft.com/office/drawing/2014/main" id="{6255753C-E26F-4667-867F-B1C3EECE3E86}"/>
+                <a16:creationId xmlns:a16="http://schemas.microsoft.com/office/drawing/2014/main" id="{BDC97481-8876-4007-94E3-F6022748D5E7}"/>
               </a:ext>
             </a:extLst>
           </p:cNvPr>
@@ -3250,7 +3290,7 @@
           <p:cNvPr id="3" name="Layout_PageNumber">
             <a:extLst xmlns:a="http://schemas.openxmlformats.org/drawingml/2006/main">
               <a:ext uri="{FF2B5EF4-FFF2-40B4-BE49-F238E27FC236}">
-                <a16:creationId xmlns:a16="http://schemas.microsoft.com/office/drawing/2014/main" id="{E8929ACD-3584-4188-864D-123F2AA9CA32}"/>
+                <a16:creationId xmlns:a16="http://schemas.microsoft.com/office/drawing/2014/main" id="{43AA41C5-7E00-4D48-909E-1263D94344D1}"/>
               </a:ext>
             </a:extLst>
           </p:cNvPr>
@@ -3335,7 +3375,7 @@
           <p:cNvPr id="4" name="Layout_Divider">
             <a:extLst xmlns:a="http://schemas.openxmlformats.org/drawingml/2006/main">
               <a:ext uri="{FF2B5EF4-FFF2-40B4-BE49-F238E27FC236}">
-                <a16:creationId xmlns:a16="http://schemas.microsoft.com/office/drawing/2014/main" id="{ADAEAF1F-5A4B-43AC-982F-612C344127BA}"/>
+                <a16:creationId xmlns:a16="http://schemas.microsoft.com/office/drawing/2014/main" id="{1515D62C-E500-49F3-ADFA-7442604F9F3D}"/>
               </a:ext>
             </a:extLst>
           </p:cNvPr>
@@ -3366,7 +3406,7 @@
           <p:cNvPr id="2" name="Layout_Footer">
             <a:extLst xmlns:a="http://schemas.openxmlformats.org/drawingml/2006/main">
               <a:ext uri="{FF2B5EF4-FFF2-40B4-BE49-F238E27FC236}">
-                <a16:creationId xmlns:a16="http://schemas.microsoft.com/office/drawing/2014/main" id="{B7D62A71-D852-40D5-BA46-FC4A99F35B9E}"/>
+                <a16:creationId xmlns:a16="http://schemas.microsoft.com/office/drawing/2014/main" id="{0EDA927B-0081-48D3-83FA-4562A076C7C3}"/>
               </a:ext>
             </a:extLst>
           </p:cNvPr>
@@ -3434,7 +3474,7 @@
           <p:cNvPr id="3" name="Layout_PageNumber">
             <a:extLst xmlns:a="http://schemas.openxmlformats.org/drawingml/2006/main">
               <a:ext uri="{FF2B5EF4-FFF2-40B4-BE49-F238E27FC236}">
-                <a16:creationId xmlns:a16="http://schemas.microsoft.com/office/drawing/2014/main" id="{632768D1-EFC5-4D6E-B8F1-C1D93F48A5E2}"/>
+                <a16:creationId xmlns:a16="http://schemas.microsoft.com/office/drawing/2014/main" id="{629DBE21-6517-4FC7-84B3-42E4AFF78230}"/>
               </a:ext>
             </a:extLst>
           </p:cNvPr>
@@ -3519,7 +3559,7 @@
           <p:cNvPr id="4" name="Layout_Divider">
             <a:extLst xmlns:a="http://schemas.openxmlformats.org/drawingml/2006/main">
               <a:ext uri="{FF2B5EF4-FFF2-40B4-BE49-F238E27FC236}">
-                <a16:creationId xmlns:a16="http://schemas.microsoft.com/office/drawing/2014/main" id="{35569339-34F6-4A93-BFF6-F4A3A3A4F75D}"/>
+                <a16:creationId xmlns:a16="http://schemas.microsoft.com/office/drawing/2014/main" id="{94ED7341-81BE-4C53-B955-1FA4017E276D}"/>
               </a:ext>
             </a:extLst>
           </p:cNvPr>
@@ -3550,7 +3590,7 @@
           <p:cNvPr id="2" name="Layout_Footer">
             <a:extLst xmlns:a="http://schemas.openxmlformats.org/drawingml/2006/main">
               <a:ext uri="{FF2B5EF4-FFF2-40B4-BE49-F238E27FC236}">
-                <a16:creationId xmlns:a16="http://schemas.microsoft.com/office/drawing/2014/main" id="{43FAF741-60DA-455E-9174-857B28595424}"/>
+                <a16:creationId xmlns:a16="http://schemas.microsoft.com/office/drawing/2014/main" id="{FAC4B3D8-2F1F-45ED-8061-F371996F6CD6}"/>
               </a:ext>
             </a:extLst>
           </p:cNvPr>
@@ -3618,7 +3658,7 @@
           <p:cNvPr id="3" name="Layout_PageNumber">
             <a:extLst xmlns:a="http://schemas.openxmlformats.org/drawingml/2006/main">
               <a:ext uri="{FF2B5EF4-FFF2-40B4-BE49-F238E27FC236}">
-                <a16:creationId xmlns:a16="http://schemas.microsoft.com/office/drawing/2014/main" id="{65B41468-BB52-4573-8245-10C45068D670}"/>
+                <a16:creationId xmlns:a16="http://schemas.microsoft.com/office/drawing/2014/main" id="{5D59DE96-1803-4869-BFD9-FC2E344FC961}"/>
               </a:ext>
             </a:extLst>
           </p:cNvPr>
@@ -3707,17 +3747,17 @@
   </p:cSld>
   <p:clrMap bg1="lt1" tx1="dk1" bg2="lt2" tx2="dk2" accent1="accent1" accent2="accent2" accent3="accent3" accent4="accent4" accent5="accent5" accent6="accent6" hlink="hlink" folHlink="folHlink"/>
   <p:sldLayoutIdLst>
-    <p:sldLayoutId xmlns:r="http://schemas.openxmlformats.org/officeDocument/2006/relationships" id="2147483649" r:id="R6fd6710909e841ec"/>
-    <p:sldLayoutId xmlns:r="http://schemas.openxmlformats.org/officeDocument/2006/relationships" id="2147483650" r:id="Rbd308f0ebe644849"/>
-    <p:sldLayoutId xmlns:r="http://schemas.openxmlformats.org/officeDocument/2006/relationships" id="2147483651" r:id="R04325fa97345414d"/>
-    <p:sldLayoutId xmlns:r="http://schemas.openxmlformats.org/officeDocument/2006/relationships" id="2147483652" r:id="R67a7a9924e824057"/>
-    <p:sldLayoutId xmlns:r="http://schemas.openxmlformats.org/officeDocument/2006/relationships" id="2147483653" r:id="R3337a6c57cdb45bb"/>
-    <p:sldLayoutId xmlns:r="http://schemas.openxmlformats.org/officeDocument/2006/relationships" id="2147483654" r:id="R5b6c92da92e74860"/>
-    <p:sldLayoutId xmlns:r="http://schemas.openxmlformats.org/officeDocument/2006/relationships" id="2147483655" r:id="R7e5318fb339247d3"/>
-    <p:sldLayoutId xmlns:r="http://schemas.openxmlformats.org/officeDocument/2006/relationships" id="2147483656" r:id="Rf5a61250a42540fc"/>
-    <p:sldLayoutId xmlns:r="http://schemas.openxmlformats.org/officeDocument/2006/relationships" id="2147483657" r:id="R99458bc6d68c4d64"/>
-    <p:sldLayoutId xmlns:r="http://schemas.openxmlformats.org/officeDocument/2006/relationships" id="2147483658" r:id="R15fa229119444bd2"/>
-    <p:sldLayoutId xmlns:r="http://schemas.openxmlformats.org/officeDocument/2006/relationships" id="2147483659" r:id="Rc65121bfa25c4752"/>
+    <p:sldLayoutId xmlns:r="http://schemas.openxmlformats.org/officeDocument/2006/relationships" id="2147483649" r:id="R11097bbef8b14fc5"/>
+    <p:sldLayoutId xmlns:r="http://schemas.openxmlformats.org/officeDocument/2006/relationships" id="2147483650" r:id="Rf532872f0b164f9e"/>
+    <p:sldLayoutId xmlns:r="http://schemas.openxmlformats.org/officeDocument/2006/relationships" id="2147483651" r:id="Rdf2e3bba27e146ee"/>
+    <p:sldLayoutId xmlns:r="http://schemas.openxmlformats.org/officeDocument/2006/relationships" id="2147483652" r:id="R12284f14beb349b3"/>
+    <p:sldLayoutId xmlns:r="http://schemas.openxmlformats.org/officeDocument/2006/relationships" id="2147483653" r:id="R63947f2830cd4184"/>
+    <p:sldLayoutId xmlns:r="http://schemas.openxmlformats.org/officeDocument/2006/relationships" id="2147483654" r:id="R2a028025dba24fb8"/>
+    <p:sldLayoutId xmlns:r="http://schemas.openxmlformats.org/officeDocument/2006/relationships" id="2147483655" r:id="Rd99c5117c5df4da0"/>
+    <p:sldLayoutId xmlns:r="http://schemas.openxmlformats.org/officeDocument/2006/relationships" id="2147483656" r:id="Rad4c713aee7049bc"/>
+    <p:sldLayoutId xmlns:r="http://schemas.openxmlformats.org/officeDocument/2006/relationships" id="2147483657" r:id="R7d52c50a90ad4c03"/>
+    <p:sldLayoutId xmlns:r="http://schemas.openxmlformats.org/officeDocument/2006/relationships" id="2147483658" r:id="R01e3c77d14334139"/>
+    <p:sldLayoutId xmlns:r="http://schemas.openxmlformats.org/officeDocument/2006/relationships" id="2147483659" r:id="R34c645f61d9d4cab"/>
   </p:sldLayoutIdLst>
   <p:txStyles>
     <p:titleStyle>
@@ -4268,7 +4308,7 @@
           <p:cNvPr id="37" name="Slide_Title">
             <a:extLst xmlns:a="http://schemas.openxmlformats.org/drawingml/2006/main">
               <a:ext uri="{FF2B5EF4-FFF2-40B4-BE49-F238E27FC236}">
-                <a16:creationId xmlns:a16="http://schemas.microsoft.com/office/drawing/2014/main" id="{0046E0B6-D726-4B79-AB16-FC3350C2DDDE}"/>
+                <a16:creationId xmlns:a16="http://schemas.microsoft.com/office/drawing/2014/main" id="{E2CF8623-FE83-437A-A021-3049C101BFEE}"/>
               </a:ext>
             </a:extLst>
           </p:cNvPr>
@@ -4336,7 +4376,7 @@
           <p:cNvPr id="2" name="Slide_Subtitle">
             <a:extLst xmlns:a="http://schemas.openxmlformats.org/drawingml/2006/main">
               <a:ext uri="{FF2B5EF4-FFF2-40B4-BE49-F238E27FC236}">
-                <a16:creationId xmlns:a16="http://schemas.microsoft.com/office/drawing/2014/main" id="{B420A6D5-CBBB-427F-B489-449066E948B5}"/>
+                <a16:creationId xmlns:a16="http://schemas.microsoft.com/office/drawing/2014/main" id="{7B245AAA-324C-4FBA-841C-B2DF8FCF378F}"/>
               </a:ext>
             </a:extLst>
           </p:cNvPr>
@@ -4404,7 +4444,7 @@
           <p:cNvPr id="3" name="S1_Flow_1">
             <a:extLst xmlns:a="http://schemas.openxmlformats.org/drawingml/2006/main">
               <a:ext uri="{FF2B5EF4-FFF2-40B4-BE49-F238E27FC236}">
-                <a16:creationId xmlns:a16="http://schemas.microsoft.com/office/drawing/2014/main" id="{42288634-5C7B-40F0-9DA2-E36AD798612C}"/>
+                <a16:creationId xmlns:a16="http://schemas.microsoft.com/office/drawing/2014/main" id="{E2A233C3-4540-46EA-84E5-30CF5A210C75}"/>
               </a:ext>
             </a:extLst>
           </p:cNvPr>
@@ -4439,7 +4479,7 @@
           <p:cNvPr id="4" name="S1_FlowIcon_1">
             <a:extLst xmlns:a="http://schemas.openxmlformats.org/drawingml/2006/main">
               <a:ext uri="{FF2B5EF4-FFF2-40B4-BE49-F238E27FC236}">
-                <a16:creationId xmlns:a16="http://schemas.microsoft.com/office/drawing/2014/main" id="{F2FF7DEF-C64F-4AE5-9F91-6C3FB73B2938}"/>
+                <a16:creationId xmlns:a16="http://schemas.microsoft.com/office/drawing/2014/main" id="{B516FC0A-4C8F-4A26-A443-E558E9E7E5D5}"/>
               </a:ext>
             </a:extLst>
           </p:cNvPr>
@@ -4510,7 +4550,7 @@
           <p:cNvPr id="5" name="S1_FlowLabel_1">
             <a:extLst xmlns:a="http://schemas.openxmlformats.org/drawingml/2006/main">
               <a:ext uri="{FF2B5EF4-FFF2-40B4-BE49-F238E27FC236}">
-                <a16:creationId xmlns:a16="http://schemas.microsoft.com/office/drawing/2014/main" id="{7BD42BEF-2024-49FF-8257-79076AA5693E}"/>
+                <a16:creationId xmlns:a16="http://schemas.microsoft.com/office/drawing/2014/main" id="{7F4A1A6D-5B36-4815-A514-0BA6F58B29E3}"/>
               </a:ext>
             </a:extLst>
           </p:cNvPr>
@@ -4578,7 +4618,7 @@
           <p:cNvPr id="6" name="S1_FlowRule_1">
             <a:extLst xmlns:a="http://schemas.openxmlformats.org/drawingml/2006/main">
               <a:ext uri="{FF2B5EF4-FFF2-40B4-BE49-F238E27FC236}">
-                <a16:creationId xmlns:a16="http://schemas.microsoft.com/office/drawing/2014/main" id="{73F1BBF4-2FA0-4F70-9D69-F3FE331B965E}"/>
+                <a16:creationId xmlns:a16="http://schemas.microsoft.com/office/drawing/2014/main" id="{EC2BF2F2-797F-4834-913A-EF207699C7A9}"/>
               </a:ext>
             </a:extLst>
           </p:cNvPr>
@@ -4609,7 +4649,7 @@
           <p:cNvPr id="7" name="S1_FlowPain_1">
             <a:extLst xmlns:a="http://schemas.openxmlformats.org/drawingml/2006/main">
               <a:ext uri="{FF2B5EF4-FFF2-40B4-BE49-F238E27FC236}">
-                <a16:creationId xmlns:a16="http://schemas.microsoft.com/office/drawing/2014/main" id="{0E1D7AE7-844F-487C-BF83-3329037AC394}"/>
+                <a16:creationId xmlns:a16="http://schemas.microsoft.com/office/drawing/2014/main" id="{418984B7-B46E-4AE2-A47A-34EC6BF0D31C}"/>
               </a:ext>
             </a:extLst>
           </p:cNvPr>
@@ -4677,7 +4717,7 @@
           <p:cNvPr id="8" name="S1_Arrow_1">
             <a:extLst xmlns:a="http://schemas.openxmlformats.org/drawingml/2006/main">
               <a:ext uri="{FF2B5EF4-FFF2-40B4-BE49-F238E27FC236}">
-                <a16:creationId xmlns:a16="http://schemas.microsoft.com/office/drawing/2014/main" id="{38C75D63-4F4C-4D12-98E5-94FC66AB19D8}"/>
+                <a16:creationId xmlns:a16="http://schemas.microsoft.com/office/drawing/2014/main" id="{4CFF9621-B385-402E-87AA-F427AFB47B56}"/>
               </a:ext>
             </a:extLst>
           </p:cNvPr>
@@ -4709,7 +4749,7 @@
           <p:cNvPr id="9" name="S1_Flow_2">
             <a:extLst xmlns:a="http://schemas.openxmlformats.org/drawingml/2006/main">
               <a:ext uri="{FF2B5EF4-FFF2-40B4-BE49-F238E27FC236}">
-                <a16:creationId xmlns:a16="http://schemas.microsoft.com/office/drawing/2014/main" id="{6B1FE9F4-3502-4DC5-940A-2D7CEA6745D0}"/>
+                <a16:creationId xmlns:a16="http://schemas.microsoft.com/office/drawing/2014/main" id="{1D0AE61F-F12B-448E-AA08-1FEE7C0DC408}"/>
               </a:ext>
             </a:extLst>
           </p:cNvPr>
@@ -4744,7 +4784,7 @@
           <p:cNvPr id="10" name="S1_FlowIcon_2">
             <a:extLst xmlns:a="http://schemas.openxmlformats.org/drawingml/2006/main">
               <a:ext uri="{FF2B5EF4-FFF2-40B4-BE49-F238E27FC236}">
-                <a16:creationId xmlns:a16="http://schemas.microsoft.com/office/drawing/2014/main" id="{94648DA7-CAAD-4C8A-B346-4DE296BCEA19}"/>
+                <a16:creationId xmlns:a16="http://schemas.microsoft.com/office/drawing/2014/main" id="{FBB2C01B-2607-4683-960F-68CB58F5F48A}"/>
               </a:ext>
             </a:extLst>
           </p:cNvPr>
@@ -4815,7 +4855,7 @@
           <p:cNvPr id="11" name="S1_FlowLabel_2">
             <a:extLst xmlns:a="http://schemas.openxmlformats.org/drawingml/2006/main">
               <a:ext uri="{FF2B5EF4-FFF2-40B4-BE49-F238E27FC236}">
-                <a16:creationId xmlns:a16="http://schemas.microsoft.com/office/drawing/2014/main" id="{F147BAE4-985B-4AD7-87A4-5AAB34D265CF}"/>
+                <a16:creationId xmlns:a16="http://schemas.microsoft.com/office/drawing/2014/main" id="{F003ECC6-E359-4FDB-B150-86E5E6C558C8}"/>
               </a:ext>
             </a:extLst>
           </p:cNvPr>
@@ -4883,7 +4923,7 @@
           <p:cNvPr id="12" name="S1_FlowRule_2">
             <a:extLst xmlns:a="http://schemas.openxmlformats.org/drawingml/2006/main">
               <a:ext uri="{FF2B5EF4-FFF2-40B4-BE49-F238E27FC236}">
-                <a16:creationId xmlns:a16="http://schemas.microsoft.com/office/drawing/2014/main" id="{0CB2037E-5279-4273-A1D1-FE3823B87B2C}"/>
+                <a16:creationId xmlns:a16="http://schemas.microsoft.com/office/drawing/2014/main" id="{94E6B246-41F0-4767-B015-82B479F93EBE}"/>
               </a:ext>
             </a:extLst>
           </p:cNvPr>
@@ -4914,7 +4954,7 @@
           <p:cNvPr id="13" name="S1_FlowPain_2">
             <a:extLst xmlns:a="http://schemas.openxmlformats.org/drawingml/2006/main">
               <a:ext uri="{FF2B5EF4-FFF2-40B4-BE49-F238E27FC236}">
-                <a16:creationId xmlns:a16="http://schemas.microsoft.com/office/drawing/2014/main" id="{1D4198A0-D5B0-4B7A-85A0-C20874FA9C35}"/>
+                <a16:creationId xmlns:a16="http://schemas.microsoft.com/office/drawing/2014/main" id="{C2D113C5-4A19-41E0-807F-740FE8F3D8CA}"/>
               </a:ext>
             </a:extLst>
           </p:cNvPr>
@@ -4982,7 +5022,7 @@
           <p:cNvPr id="14" name="S1_Arrow_2">
             <a:extLst xmlns:a="http://schemas.openxmlformats.org/drawingml/2006/main">
               <a:ext uri="{FF2B5EF4-FFF2-40B4-BE49-F238E27FC236}">
-                <a16:creationId xmlns:a16="http://schemas.microsoft.com/office/drawing/2014/main" id="{9C69EB71-FFD1-4831-859D-3DAE6A612D7E}"/>
+                <a16:creationId xmlns:a16="http://schemas.microsoft.com/office/drawing/2014/main" id="{9DFAF7C0-5829-4D80-A536-B2EF47B90C96}"/>
               </a:ext>
             </a:extLst>
           </p:cNvPr>
@@ -5014,7 +5054,7 @@
           <p:cNvPr id="15" name="S1_Flow_3">
             <a:extLst xmlns:a="http://schemas.openxmlformats.org/drawingml/2006/main">
               <a:ext uri="{FF2B5EF4-FFF2-40B4-BE49-F238E27FC236}">
-                <a16:creationId xmlns:a16="http://schemas.microsoft.com/office/drawing/2014/main" id="{6ABB322D-B348-4133-B318-E8A69005DB3B}"/>
+                <a16:creationId xmlns:a16="http://schemas.microsoft.com/office/drawing/2014/main" id="{6C17EF87-12B9-4775-BAB0-0AD58FE687FD}"/>
               </a:ext>
             </a:extLst>
           </p:cNvPr>
@@ -5049,7 +5089,7 @@
           <p:cNvPr id="16" name="S1_FlowIcon_3">
             <a:extLst xmlns:a="http://schemas.openxmlformats.org/drawingml/2006/main">
               <a:ext uri="{FF2B5EF4-FFF2-40B4-BE49-F238E27FC236}">
-                <a16:creationId xmlns:a16="http://schemas.microsoft.com/office/drawing/2014/main" id="{6B75A82C-D548-4831-8CB1-49F82EFDE4A3}"/>
+                <a16:creationId xmlns:a16="http://schemas.microsoft.com/office/drawing/2014/main" id="{BE0D718B-531A-45BF-9911-03BC8757F07B}"/>
               </a:ext>
             </a:extLst>
           </p:cNvPr>
@@ -5120,7 +5160,7 @@
           <p:cNvPr id="17" name="S1_FlowLabel_3">
             <a:extLst xmlns:a="http://schemas.openxmlformats.org/drawingml/2006/main">
               <a:ext uri="{FF2B5EF4-FFF2-40B4-BE49-F238E27FC236}">
-                <a16:creationId xmlns:a16="http://schemas.microsoft.com/office/drawing/2014/main" id="{5BF3827A-6CB7-43E7-957B-E41D0B758314}"/>
+                <a16:creationId xmlns:a16="http://schemas.microsoft.com/office/drawing/2014/main" id="{61021868-C20A-4C6E-8D24-8693726CF9A4}"/>
               </a:ext>
             </a:extLst>
           </p:cNvPr>
@@ -5188,7 +5228,7 @@
           <p:cNvPr id="18" name="S1_FlowRule_3">
             <a:extLst xmlns:a="http://schemas.openxmlformats.org/drawingml/2006/main">
               <a:ext uri="{FF2B5EF4-FFF2-40B4-BE49-F238E27FC236}">
-                <a16:creationId xmlns:a16="http://schemas.microsoft.com/office/drawing/2014/main" id="{EFC0BD91-ADEE-4FB6-917F-46D28B043878}"/>
+                <a16:creationId xmlns:a16="http://schemas.microsoft.com/office/drawing/2014/main" id="{603A7B99-DEC0-4ABF-9C29-FB48EE961670}"/>
               </a:ext>
             </a:extLst>
           </p:cNvPr>
@@ -5219,7 +5259,7 @@
           <p:cNvPr id="19" name="S1_FlowPain_3">
             <a:extLst xmlns:a="http://schemas.openxmlformats.org/drawingml/2006/main">
               <a:ext uri="{FF2B5EF4-FFF2-40B4-BE49-F238E27FC236}">
-                <a16:creationId xmlns:a16="http://schemas.microsoft.com/office/drawing/2014/main" id="{87FB16FA-1D19-477B-A122-6CAB87C9BD9A}"/>
+                <a16:creationId xmlns:a16="http://schemas.microsoft.com/office/drawing/2014/main" id="{E0DD22B9-5301-46CE-8CD6-9A175DA43E0D}"/>
               </a:ext>
             </a:extLst>
           </p:cNvPr>
@@ -5287,7 +5327,7 @@
           <p:cNvPr id="20" name="S1_Arrow_3">
             <a:extLst xmlns:a="http://schemas.openxmlformats.org/drawingml/2006/main">
               <a:ext uri="{FF2B5EF4-FFF2-40B4-BE49-F238E27FC236}">
-                <a16:creationId xmlns:a16="http://schemas.microsoft.com/office/drawing/2014/main" id="{0BE28038-5EA9-4FB3-AE9C-C837DED518A4}"/>
+                <a16:creationId xmlns:a16="http://schemas.microsoft.com/office/drawing/2014/main" id="{295AC98A-52B5-4F82-96CC-8E3827914CB8}"/>
               </a:ext>
             </a:extLst>
           </p:cNvPr>
@@ -5319,7 +5359,7 @@
           <p:cNvPr id="21" name="S1_Flow_4">
             <a:extLst xmlns:a="http://schemas.openxmlformats.org/drawingml/2006/main">
               <a:ext uri="{FF2B5EF4-FFF2-40B4-BE49-F238E27FC236}">
-                <a16:creationId xmlns:a16="http://schemas.microsoft.com/office/drawing/2014/main" id="{2FBF00F7-4B79-4032-97B2-F6CC6D3EE09D}"/>
+                <a16:creationId xmlns:a16="http://schemas.microsoft.com/office/drawing/2014/main" id="{3CE7DD19-E5A5-45AD-B77C-C13F506362D9}"/>
               </a:ext>
             </a:extLst>
           </p:cNvPr>
@@ -5354,7 +5394,7 @@
           <p:cNvPr id="22" name="S1_FlowIcon_4">
             <a:extLst xmlns:a="http://schemas.openxmlformats.org/drawingml/2006/main">
               <a:ext uri="{FF2B5EF4-FFF2-40B4-BE49-F238E27FC236}">
-                <a16:creationId xmlns:a16="http://schemas.microsoft.com/office/drawing/2014/main" id="{24419722-4ED1-4470-BE11-5FEC9E93552E}"/>
+                <a16:creationId xmlns:a16="http://schemas.microsoft.com/office/drawing/2014/main" id="{01BF0624-C114-4FE6-A5A8-F17C021D2BB4}"/>
               </a:ext>
             </a:extLst>
           </p:cNvPr>
@@ -5425,7 +5465,7 @@
           <p:cNvPr id="23" name="S1_FlowLabel_4">
             <a:extLst xmlns:a="http://schemas.openxmlformats.org/drawingml/2006/main">
               <a:ext uri="{FF2B5EF4-FFF2-40B4-BE49-F238E27FC236}">
-                <a16:creationId xmlns:a16="http://schemas.microsoft.com/office/drawing/2014/main" id="{B7010B80-DA74-4768-BB72-193D4D7AD86A}"/>
+                <a16:creationId xmlns:a16="http://schemas.microsoft.com/office/drawing/2014/main" id="{D2ABF8BA-31DA-4FCB-9F4F-F497DD07F4DC}"/>
               </a:ext>
             </a:extLst>
           </p:cNvPr>
@@ -5493,7 +5533,7 @@
           <p:cNvPr id="24" name="S1_FlowRule_4">
             <a:extLst xmlns:a="http://schemas.openxmlformats.org/drawingml/2006/main">
               <a:ext uri="{FF2B5EF4-FFF2-40B4-BE49-F238E27FC236}">
-                <a16:creationId xmlns:a16="http://schemas.microsoft.com/office/drawing/2014/main" id="{0325E642-EC11-4F2F-AC1C-101394E34CFC}"/>
+                <a16:creationId xmlns:a16="http://schemas.microsoft.com/office/drawing/2014/main" id="{EA8D7EB2-DE68-4D43-A5C7-009D2B3A6366}"/>
               </a:ext>
             </a:extLst>
           </p:cNvPr>
@@ -5524,7 +5564,7 @@
           <p:cNvPr id="25" name="S1_FlowPain_4">
             <a:extLst xmlns:a="http://schemas.openxmlformats.org/drawingml/2006/main">
               <a:ext uri="{FF2B5EF4-FFF2-40B4-BE49-F238E27FC236}">
-                <a16:creationId xmlns:a16="http://schemas.microsoft.com/office/drawing/2014/main" id="{D64D9981-9AA0-4943-8C31-0290C1B499ED}"/>
+                <a16:creationId xmlns:a16="http://schemas.microsoft.com/office/drawing/2014/main" id="{A8D69C97-05EA-445D-A9AA-4B1656606119}"/>
               </a:ext>
             </a:extLst>
           </p:cNvPr>
@@ -5592,7 +5632,7 @@
           <p:cNvPr id="26" name="S1_Arrow_4">
             <a:extLst xmlns:a="http://schemas.openxmlformats.org/drawingml/2006/main">
               <a:ext uri="{FF2B5EF4-FFF2-40B4-BE49-F238E27FC236}">
-                <a16:creationId xmlns:a16="http://schemas.microsoft.com/office/drawing/2014/main" id="{BFD4B34D-9D5D-4D4E-B63B-2C31866EABDA}"/>
+                <a16:creationId xmlns:a16="http://schemas.microsoft.com/office/drawing/2014/main" id="{7A542CCC-DFBF-4AA7-A2A5-D5B755699633}"/>
               </a:ext>
             </a:extLst>
           </p:cNvPr>
@@ -5624,7 +5664,7 @@
           <p:cNvPr id="27" name="S1_Flow_5">
             <a:extLst xmlns:a="http://schemas.openxmlformats.org/drawingml/2006/main">
               <a:ext uri="{FF2B5EF4-FFF2-40B4-BE49-F238E27FC236}">
-                <a16:creationId xmlns:a16="http://schemas.microsoft.com/office/drawing/2014/main" id="{5F879AE2-F61B-4151-A8D4-18D626F6A3E9}"/>
+                <a16:creationId xmlns:a16="http://schemas.microsoft.com/office/drawing/2014/main" id="{6E9BC3BF-54D9-4BD6-B582-9DB5A8755529}"/>
               </a:ext>
             </a:extLst>
           </p:cNvPr>
@@ -5659,7 +5699,7 @@
           <p:cNvPr id="28" name="S1_FlowIcon_5">
             <a:extLst xmlns:a="http://schemas.openxmlformats.org/drawingml/2006/main">
               <a:ext uri="{FF2B5EF4-FFF2-40B4-BE49-F238E27FC236}">
-                <a16:creationId xmlns:a16="http://schemas.microsoft.com/office/drawing/2014/main" id="{BAC4B12E-BBAB-45F7-8B55-5172ACE6B6DF}"/>
+                <a16:creationId xmlns:a16="http://schemas.microsoft.com/office/drawing/2014/main" id="{09BD655C-4CDC-46EC-B39F-BE4F526ED742}"/>
               </a:ext>
             </a:extLst>
           </p:cNvPr>
@@ -5730,7 +5770,7 @@
           <p:cNvPr id="29" name="S1_FlowLabel_5">
             <a:extLst xmlns:a="http://schemas.openxmlformats.org/drawingml/2006/main">
               <a:ext uri="{FF2B5EF4-FFF2-40B4-BE49-F238E27FC236}">
-                <a16:creationId xmlns:a16="http://schemas.microsoft.com/office/drawing/2014/main" id="{2160BDB6-A37F-4189-8E19-D894D26CAAF6}"/>
+                <a16:creationId xmlns:a16="http://schemas.microsoft.com/office/drawing/2014/main" id="{070630E1-DD9D-4EDB-8566-6F0D2C30F7F8}"/>
               </a:ext>
             </a:extLst>
           </p:cNvPr>
@@ -5798,7 +5838,7 @@
           <p:cNvPr id="30" name="S1_FlowRule_5">
             <a:extLst xmlns:a="http://schemas.openxmlformats.org/drawingml/2006/main">
               <a:ext uri="{FF2B5EF4-FFF2-40B4-BE49-F238E27FC236}">
-                <a16:creationId xmlns:a16="http://schemas.microsoft.com/office/drawing/2014/main" id="{6EE7C5E0-1F84-48F2-BFD9-578C595BA4F8}"/>
+                <a16:creationId xmlns:a16="http://schemas.microsoft.com/office/drawing/2014/main" id="{8B11D74B-7737-48B7-B6E7-C569403BE008}"/>
               </a:ext>
             </a:extLst>
           </p:cNvPr>
@@ -5829,7 +5869,7 @@
           <p:cNvPr id="31" name="S1_FlowPain_5">
             <a:extLst xmlns:a="http://schemas.openxmlformats.org/drawingml/2006/main">
               <a:ext uri="{FF2B5EF4-FFF2-40B4-BE49-F238E27FC236}">
-                <a16:creationId xmlns:a16="http://schemas.microsoft.com/office/drawing/2014/main" id="{5438B1D7-B8C5-4D17-80FA-B9F3B49CC208}"/>
+                <a16:creationId xmlns:a16="http://schemas.microsoft.com/office/drawing/2014/main" id="{E7D02F4E-DE95-475E-83E0-50F8895A23E9}"/>
               </a:ext>
             </a:extLst>
           </p:cNvPr>
@@ -5897,7 +5937,7 @@
           <p:cNvPr id="32" name="S1_GapBand">
             <a:extLst xmlns:a="http://schemas.openxmlformats.org/drawingml/2006/main">
               <a:ext uri="{FF2B5EF4-FFF2-40B4-BE49-F238E27FC236}">
-                <a16:creationId xmlns:a16="http://schemas.microsoft.com/office/drawing/2014/main" id="{AC5311E6-C821-42B4-9A16-D614CDE97DA7}"/>
+                <a16:creationId xmlns:a16="http://schemas.microsoft.com/office/drawing/2014/main" id="{6738B840-D910-4BB3-A61E-DA77F1AE6B5E}"/>
               </a:ext>
             </a:extLst>
           </p:cNvPr>
@@ -5932,7 +5972,7 @@
           <p:cNvPr id="33" name="S1_GapLabel">
             <a:extLst xmlns:a="http://schemas.openxmlformats.org/drawingml/2006/main">
               <a:ext uri="{FF2B5EF4-FFF2-40B4-BE49-F238E27FC236}">
-                <a16:creationId xmlns:a16="http://schemas.microsoft.com/office/drawing/2014/main" id="{547BFEBA-45B2-47DA-AB42-71461F7B169C}"/>
+                <a16:creationId xmlns:a16="http://schemas.microsoft.com/office/drawing/2014/main" id="{BED3F765-D072-4DAA-868F-0278980CCD45}"/>
               </a:ext>
             </a:extLst>
           </p:cNvPr>
@@ -6000,7 +6040,7 @@
           <p:cNvPr id="34" name="S1_GapText">
             <a:extLst xmlns:a="http://schemas.openxmlformats.org/drawingml/2006/main">
               <a:ext uri="{FF2B5EF4-FFF2-40B4-BE49-F238E27FC236}">
-                <a16:creationId xmlns:a16="http://schemas.microsoft.com/office/drawing/2014/main" id="{0B357E71-F1CC-47DC-9C29-CE06F42C0247}"/>
+                <a16:creationId xmlns:a16="http://schemas.microsoft.com/office/drawing/2014/main" id="{AAF397B6-A2F4-46A4-B33D-1C59CC2442CB}"/>
               </a:ext>
             </a:extLst>
           </p:cNvPr>
@@ -6068,7 +6108,7 @@
           <p:cNvPr id="35" name="S1_BridgeRule">
             <a:extLst xmlns:a="http://schemas.openxmlformats.org/drawingml/2006/main">
               <a:ext uri="{FF2B5EF4-FFF2-40B4-BE49-F238E27FC236}">
-                <a16:creationId xmlns:a16="http://schemas.microsoft.com/office/drawing/2014/main" id="{76BDC260-17A4-4E7D-B03E-CBE493AA5C40}"/>
+                <a16:creationId xmlns:a16="http://schemas.microsoft.com/office/drawing/2014/main" id="{D373A18F-17D2-420C-BC6F-B31E9F2FAEBC}"/>
               </a:ext>
             </a:extLst>
           </p:cNvPr>
@@ -6099,7 +6139,7 @@
           <p:cNvPr id="36" name="S1_Bridge">
             <a:extLst xmlns:a="http://schemas.openxmlformats.org/drawingml/2006/main">
               <a:ext uri="{FF2B5EF4-FFF2-40B4-BE49-F238E27FC236}">
-                <a16:creationId xmlns:a16="http://schemas.microsoft.com/office/drawing/2014/main" id="{A814B0EA-F40A-4E3C-A4A7-4957D9D0FB6F}"/>
+                <a16:creationId xmlns:a16="http://schemas.microsoft.com/office/drawing/2014/main" id="{C53CCACE-24F6-4880-AAC4-DA6803F3FC27}"/>
               </a:ext>
             </a:extLst>
           </p:cNvPr>
@@ -6165,7 +6205,7 @@
     </p:spTree>
     <p:extLst>
       <p:ext uri="{BB962C8B-B14F-4D97-AF65-F5344CB8AC3E}">
-        <p14:creationId xmlns:p14="http://schemas.microsoft.com/office/powerpoint/2010/main" val="1431627127"/>
+        <p14:creationId xmlns:p14="http://schemas.microsoft.com/office/powerpoint/2010/main" val="1719395012"/>
       </p:ext>
     </p:extLst>
   </p:cSld>
@@ -6196,7 +6236,7 @@
           <p:cNvPr id="41" name="Slide_Title">
             <a:extLst xmlns:a="http://schemas.openxmlformats.org/drawingml/2006/main">
               <a:ext uri="{FF2B5EF4-FFF2-40B4-BE49-F238E27FC236}">
-                <a16:creationId xmlns:a16="http://schemas.microsoft.com/office/drawing/2014/main" id="{5A28A4AF-BE54-4A1A-9F9D-82D0992ED6BC}"/>
+                <a16:creationId xmlns:a16="http://schemas.microsoft.com/office/drawing/2014/main" id="{15BF8DF5-C4AC-4470-8994-A7D9F1824997}"/>
               </a:ext>
             </a:extLst>
           </p:cNvPr>
@@ -6264,7 +6304,7 @@
           <p:cNvPr id="2" name="Slide_Subtitle">
             <a:extLst xmlns:a="http://schemas.openxmlformats.org/drawingml/2006/main">
               <a:ext uri="{FF2B5EF4-FFF2-40B4-BE49-F238E27FC236}">
-                <a16:creationId xmlns:a16="http://schemas.microsoft.com/office/drawing/2014/main" id="{0B56A590-765F-43B5-80E3-2521CA8593C1}"/>
+                <a16:creationId xmlns:a16="http://schemas.microsoft.com/office/drawing/2014/main" id="{E0D185DD-9435-431E-81F1-8289EB3D929C}"/>
               </a:ext>
             </a:extLst>
           </p:cNvPr>
@@ -6332,7 +6372,7 @@
           <p:cNvPr id="3" name="S2_Column_1">
             <a:extLst xmlns:a="http://schemas.openxmlformats.org/drawingml/2006/main">
               <a:ext uri="{FF2B5EF4-FFF2-40B4-BE49-F238E27FC236}">
-                <a16:creationId xmlns:a16="http://schemas.microsoft.com/office/drawing/2014/main" id="{3D647ABB-06E6-45DF-A9F4-656FFB4335EB}"/>
+                <a16:creationId xmlns:a16="http://schemas.microsoft.com/office/drawing/2014/main" id="{D0DFD8E6-38EF-4537-B90D-56ED107CA752}"/>
               </a:ext>
             </a:extLst>
           </p:cNvPr>
@@ -6400,7 +6440,7 @@
           <p:cNvPr id="4" name="S2_Column_2">
             <a:extLst xmlns:a="http://schemas.openxmlformats.org/drawingml/2006/main">
               <a:ext uri="{FF2B5EF4-FFF2-40B4-BE49-F238E27FC236}">
-                <a16:creationId xmlns:a16="http://schemas.microsoft.com/office/drawing/2014/main" id="{D298B876-43AD-4FC5-A105-8ADD794A4C28}"/>
+                <a16:creationId xmlns:a16="http://schemas.microsoft.com/office/drawing/2014/main" id="{5D3342B3-11BB-4C05-8757-15A7A6208F30}"/>
               </a:ext>
             </a:extLst>
           </p:cNvPr>
@@ -6468,7 +6508,7 @@
           <p:cNvPr id="5" name="S2_Column_3">
             <a:extLst xmlns:a="http://schemas.openxmlformats.org/drawingml/2006/main">
               <a:ext uri="{FF2B5EF4-FFF2-40B4-BE49-F238E27FC236}">
-                <a16:creationId xmlns:a16="http://schemas.microsoft.com/office/drawing/2014/main" id="{F8EE1C2A-B1E1-4B18-89D7-214D595864C8}"/>
+                <a16:creationId xmlns:a16="http://schemas.microsoft.com/office/drawing/2014/main" id="{DD76CD4A-D448-4FB7-84B0-196C7B2BEB52}"/>
               </a:ext>
             </a:extLst>
           </p:cNvPr>
@@ -6536,7 +6576,7 @@
           <p:cNvPr id="6" name="S2_SystemLabel">
             <a:extLst xmlns:a="http://schemas.openxmlformats.org/drawingml/2006/main">
               <a:ext uri="{FF2B5EF4-FFF2-40B4-BE49-F238E27FC236}">
-                <a16:creationId xmlns:a16="http://schemas.microsoft.com/office/drawing/2014/main" id="{BFDCD67B-C558-4B43-871D-4D2B69967EDC}"/>
+                <a16:creationId xmlns:a16="http://schemas.microsoft.com/office/drawing/2014/main" id="{50EF992B-90E6-42BD-896B-5453E13654B0}"/>
               </a:ext>
             </a:extLst>
           </p:cNvPr>
@@ -6571,7 +6611,7 @@
           <p:cNvPr id="7" name="S2_SystemLabelText">
             <a:extLst xmlns:a="http://schemas.openxmlformats.org/drawingml/2006/main">
               <a:ext uri="{FF2B5EF4-FFF2-40B4-BE49-F238E27FC236}">
-                <a16:creationId xmlns:a16="http://schemas.microsoft.com/office/drawing/2014/main" id="{A3D10932-0426-4251-A5D2-89928E2E7FCA}"/>
+                <a16:creationId xmlns:a16="http://schemas.microsoft.com/office/drawing/2014/main" id="{0610A829-145D-49FD-A5F5-3D83A853655A}"/>
               </a:ext>
             </a:extLst>
           </p:cNvPr>
@@ -6639,7 +6679,7 @@
           <p:cNvPr id="8" name="S2_HumanLabel">
             <a:extLst xmlns:a="http://schemas.openxmlformats.org/drawingml/2006/main">
               <a:ext uri="{FF2B5EF4-FFF2-40B4-BE49-F238E27FC236}">
-                <a16:creationId xmlns:a16="http://schemas.microsoft.com/office/drawing/2014/main" id="{34881E87-618B-458C-B21A-5AC40809C4AB}"/>
+                <a16:creationId xmlns:a16="http://schemas.microsoft.com/office/drawing/2014/main" id="{9D2677C3-85B0-4C7B-85A5-0B0F99A0A43C}"/>
               </a:ext>
             </a:extLst>
           </p:cNvPr>
@@ -6674,7 +6714,7 @@
           <p:cNvPr id="9" name="S2_HumanLabelText">
             <a:extLst xmlns:a="http://schemas.openxmlformats.org/drawingml/2006/main">
               <a:ext uri="{FF2B5EF4-FFF2-40B4-BE49-F238E27FC236}">
-                <a16:creationId xmlns:a16="http://schemas.microsoft.com/office/drawing/2014/main" id="{BCB85500-3508-4902-B967-80FCB3F8C130}"/>
+                <a16:creationId xmlns:a16="http://schemas.microsoft.com/office/drawing/2014/main" id="{0E2E380A-6E3B-4640-B2C4-8FA0D64F817F}"/>
               </a:ext>
             </a:extLst>
           </p:cNvPr>
@@ -6742,7 +6782,7 @@
           <p:cNvPr id="10" name="S2_InputSystem">
             <a:extLst xmlns:a="http://schemas.openxmlformats.org/drawingml/2006/main">
               <a:ext uri="{FF2B5EF4-FFF2-40B4-BE49-F238E27FC236}">
-                <a16:creationId xmlns:a16="http://schemas.microsoft.com/office/drawing/2014/main" id="{FF55B65F-3C7A-4A07-9F07-5A6D4357B464}"/>
+                <a16:creationId xmlns:a16="http://schemas.microsoft.com/office/drawing/2014/main" id="{347276DF-6AF3-4C07-A161-11B54B53FBD2}"/>
               </a:ext>
             </a:extLst>
           </p:cNvPr>
@@ -6777,7 +6817,7 @@
           <p:cNvPr id="11" name="S2_PhaseA">
             <a:extLst xmlns:a="http://schemas.openxmlformats.org/drawingml/2006/main">
               <a:ext uri="{FF2B5EF4-FFF2-40B4-BE49-F238E27FC236}">
-                <a16:creationId xmlns:a16="http://schemas.microsoft.com/office/drawing/2014/main" id="{76F65E86-8E6E-4DD2-A7FE-89FB69C7E8DC}"/>
+                <a16:creationId xmlns:a16="http://schemas.microsoft.com/office/drawing/2014/main" id="{5DD3D1FB-FD9D-4FDE-9D8D-26A56B53221B}"/>
               </a:ext>
             </a:extLst>
           </p:cNvPr>
@@ -6852,7 +6892,7 @@
           <p:cNvPr id="12" name="S2_PhaseATitle">
             <a:extLst xmlns:a="http://schemas.openxmlformats.org/drawingml/2006/main">
               <a:ext uri="{FF2B5EF4-FFF2-40B4-BE49-F238E27FC236}">
-                <a16:creationId xmlns:a16="http://schemas.microsoft.com/office/drawing/2014/main" id="{07A58BF2-2856-4013-832D-42C64C4A05AB}"/>
+                <a16:creationId xmlns:a16="http://schemas.microsoft.com/office/drawing/2014/main" id="{35D7AFEE-C0D1-4C9A-A478-1E6EEC6F3571}"/>
               </a:ext>
             </a:extLst>
           </p:cNvPr>
@@ -6920,7 +6960,7 @@
           <p:cNvPr id="13" name="S2_PhaseADetail">
             <a:extLst xmlns:a="http://schemas.openxmlformats.org/drawingml/2006/main">
               <a:ext uri="{FF2B5EF4-FFF2-40B4-BE49-F238E27FC236}">
-                <a16:creationId xmlns:a16="http://schemas.microsoft.com/office/drawing/2014/main" id="{4FC5683E-B1A6-45A2-A7AC-2AB22DB51BEC}"/>
+                <a16:creationId xmlns:a16="http://schemas.microsoft.com/office/drawing/2014/main" id="{845BF41C-8AA6-449A-9E46-B2C0E656DB06}"/>
               </a:ext>
             </a:extLst>
           </p:cNvPr>
@@ -7057,7 +7097,7 @@
           <p:cNvPr id="14" name="S2_ProcessSystem">
             <a:extLst xmlns:a="http://schemas.openxmlformats.org/drawingml/2006/main">
               <a:ext uri="{FF2B5EF4-FFF2-40B4-BE49-F238E27FC236}">
-                <a16:creationId xmlns:a16="http://schemas.microsoft.com/office/drawing/2014/main" id="{2425F454-EFB7-4BC8-B5CA-CB19C578277E}"/>
+                <a16:creationId xmlns:a16="http://schemas.microsoft.com/office/drawing/2014/main" id="{509BDA9D-2FD5-4F1C-B349-478BE1658EF6}"/>
               </a:ext>
             </a:extLst>
           </p:cNvPr>
@@ -7092,7 +7132,7 @@
           <p:cNvPr id="15" name="S2_PhaseB">
             <a:extLst xmlns:a="http://schemas.openxmlformats.org/drawingml/2006/main">
               <a:ext uri="{FF2B5EF4-FFF2-40B4-BE49-F238E27FC236}">
-                <a16:creationId xmlns:a16="http://schemas.microsoft.com/office/drawing/2014/main" id="{9F4A2226-BE65-4670-8513-733FE3C9DC2C}"/>
+                <a16:creationId xmlns:a16="http://schemas.microsoft.com/office/drawing/2014/main" id="{9EF2199D-D19F-4C12-98D3-CD8E22E864FC}"/>
               </a:ext>
             </a:extLst>
           </p:cNvPr>
@@ -7167,7 +7207,7 @@
           <p:cNvPr id="16" name="S2_PhaseBDetail">
             <a:extLst xmlns:a="http://schemas.openxmlformats.org/drawingml/2006/main">
               <a:ext uri="{FF2B5EF4-FFF2-40B4-BE49-F238E27FC236}">
-                <a16:creationId xmlns:a16="http://schemas.microsoft.com/office/drawing/2014/main" id="{3D070A38-3270-4F32-A126-2E9C91BC80F8}"/>
+                <a16:creationId xmlns:a16="http://schemas.microsoft.com/office/drawing/2014/main" id="{6E9E70CA-21B1-427F-88A0-C202FBD31AD8}"/>
               </a:ext>
             </a:extLst>
           </p:cNvPr>
@@ -7258,7 +7298,7 @@
           <p:cNvPr id="17" name="S2_ProcessDivider">
             <a:extLst xmlns:a="http://schemas.openxmlformats.org/drawingml/2006/main">
               <a:ext uri="{FF2B5EF4-FFF2-40B4-BE49-F238E27FC236}">
-                <a16:creationId xmlns:a16="http://schemas.microsoft.com/office/drawing/2014/main" id="{23B3121F-E625-4894-818C-973B34881EE0}"/>
+                <a16:creationId xmlns:a16="http://schemas.microsoft.com/office/drawing/2014/main" id="{031F29D9-49F6-432F-90A3-71F23E4E8D7D}"/>
               </a:ext>
             </a:extLst>
           </p:cNvPr>
@@ -7289,7 +7329,7 @@
           <p:cNvPr id="18" name="S2_PhaseC">
             <a:extLst xmlns:a="http://schemas.openxmlformats.org/drawingml/2006/main">
               <a:ext uri="{FF2B5EF4-FFF2-40B4-BE49-F238E27FC236}">
-                <a16:creationId xmlns:a16="http://schemas.microsoft.com/office/drawing/2014/main" id="{611008E2-E6CC-4DE7-9FC3-2D0D41D26697}"/>
+                <a16:creationId xmlns:a16="http://schemas.microsoft.com/office/drawing/2014/main" id="{DC75EACC-E172-420F-9384-9A934581C0C5}"/>
               </a:ext>
             </a:extLst>
           </p:cNvPr>
@@ -7364,7 +7404,7 @@
           <p:cNvPr id="19" name="S2_PhaseCDetail">
             <a:extLst xmlns:a="http://schemas.openxmlformats.org/drawingml/2006/main">
               <a:ext uri="{FF2B5EF4-FFF2-40B4-BE49-F238E27FC236}">
-                <a16:creationId xmlns:a16="http://schemas.microsoft.com/office/drawing/2014/main" id="{4403E1DB-435A-4074-8820-DC7854921D8F}"/>
+                <a16:creationId xmlns:a16="http://schemas.microsoft.com/office/drawing/2014/main" id="{439901C9-0DF3-4452-B762-141414319411}"/>
               </a:ext>
             </a:extLst>
           </p:cNvPr>
@@ -7455,7 +7495,7 @@
           <p:cNvPr id="20" name="S2_OutputSystem">
             <a:extLst xmlns:a="http://schemas.openxmlformats.org/drawingml/2006/main">
               <a:ext uri="{FF2B5EF4-FFF2-40B4-BE49-F238E27FC236}">
-                <a16:creationId xmlns:a16="http://schemas.microsoft.com/office/drawing/2014/main" id="{9062DFD3-0BC6-4303-8300-085BFCE8E776}"/>
+                <a16:creationId xmlns:a16="http://schemas.microsoft.com/office/drawing/2014/main" id="{478BC85D-40C4-4819-920A-7EB1FE8815D4}"/>
               </a:ext>
             </a:extLst>
           </p:cNvPr>
@@ -7490,7 +7530,7 @@
           <p:cNvPr id="21" name="S2_PhaseD">
             <a:extLst xmlns:a="http://schemas.openxmlformats.org/drawingml/2006/main">
               <a:ext uri="{FF2B5EF4-FFF2-40B4-BE49-F238E27FC236}">
-                <a16:creationId xmlns:a16="http://schemas.microsoft.com/office/drawing/2014/main" id="{9B8CB60F-C4B6-46AA-9B30-2A0C45E063A6}"/>
+                <a16:creationId xmlns:a16="http://schemas.microsoft.com/office/drawing/2014/main" id="{1CD96D33-880F-4CE2-8256-84069A5D7716}"/>
               </a:ext>
             </a:extLst>
           </p:cNvPr>
@@ -7565,7 +7605,7 @@
           <p:cNvPr id="22" name="S2_PhaseDTitle">
             <a:extLst xmlns:a="http://schemas.openxmlformats.org/drawingml/2006/main">
               <a:ext uri="{FF2B5EF4-FFF2-40B4-BE49-F238E27FC236}">
-                <a16:creationId xmlns:a16="http://schemas.microsoft.com/office/drawing/2014/main" id="{B39D51BC-3F7B-4015-A105-2E977EFF4251}"/>
+                <a16:creationId xmlns:a16="http://schemas.microsoft.com/office/drawing/2014/main" id="{DD8B0CDD-F906-4369-AD3A-EFDBB2111AD7}"/>
               </a:ext>
             </a:extLst>
           </p:cNvPr>
@@ -7633,7 +7673,7 @@
           <p:cNvPr id="23" name="S2_PhaseDDetail">
             <a:extLst xmlns:a="http://schemas.openxmlformats.org/drawingml/2006/main">
               <a:ext uri="{FF2B5EF4-FFF2-40B4-BE49-F238E27FC236}">
-                <a16:creationId xmlns:a16="http://schemas.microsoft.com/office/drawing/2014/main" id="{5A85AC92-7CF1-40C0-90A1-2E0A17C108D7}"/>
+                <a16:creationId xmlns:a16="http://schemas.microsoft.com/office/drawing/2014/main" id="{DBEDF330-B8C9-4DF7-A896-095BC74730BE}"/>
               </a:ext>
             </a:extLst>
           </p:cNvPr>
@@ -7724,7 +7764,7 @@
           <p:cNvPr id="24" name="S2_AutoBranch">
             <a:extLst xmlns:a="http://schemas.openxmlformats.org/drawingml/2006/main">
               <a:ext uri="{FF2B5EF4-FFF2-40B4-BE49-F238E27FC236}">
-                <a16:creationId xmlns:a16="http://schemas.microsoft.com/office/drawing/2014/main" id="{EBF4D78E-70D3-4CB0-B70B-7533AF752F5E}"/>
+                <a16:creationId xmlns:a16="http://schemas.microsoft.com/office/drawing/2014/main" id="{ED8BCCDA-797B-4FEF-973B-1424324E4A13}"/>
               </a:ext>
             </a:extLst>
           </p:cNvPr>
@@ -7759,7 +7799,7 @@
           <p:cNvPr id="25" name="S2_AutoBranchText">
             <a:extLst xmlns:a="http://schemas.openxmlformats.org/drawingml/2006/main">
               <a:ext uri="{FF2B5EF4-FFF2-40B4-BE49-F238E27FC236}">
-                <a16:creationId xmlns:a16="http://schemas.microsoft.com/office/drawing/2014/main" id="{7CDCF165-868D-4E38-BBB2-D458E48281CA}"/>
+                <a16:creationId xmlns:a16="http://schemas.microsoft.com/office/drawing/2014/main" id="{39F5CA20-2B1C-4ED6-B556-B65115E4EFF0}"/>
               </a:ext>
             </a:extLst>
           </p:cNvPr>
@@ -7850,7 +7890,7 @@
           <p:cNvPr id="26" name="S2_EscalateBranch">
             <a:extLst xmlns:a="http://schemas.openxmlformats.org/drawingml/2006/main">
               <a:ext uri="{FF2B5EF4-FFF2-40B4-BE49-F238E27FC236}">
-                <a16:creationId xmlns:a16="http://schemas.microsoft.com/office/drawing/2014/main" id="{4B9392A2-090B-4ACF-BA58-56CD18DE3976}"/>
+                <a16:creationId xmlns:a16="http://schemas.microsoft.com/office/drawing/2014/main" id="{324C34A9-D651-42A8-A452-C383840F6628}"/>
               </a:ext>
             </a:extLst>
           </p:cNvPr>
@@ -7885,7 +7925,7 @@
           <p:cNvPr id="27" name="S2_EscalateBranchText">
             <a:extLst xmlns:a="http://schemas.openxmlformats.org/drawingml/2006/main">
               <a:ext uri="{FF2B5EF4-FFF2-40B4-BE49-F238E27FC236}">
-                <a16:creationId xmlns:a16="http://schemas.microsoft.com/office/drawing/2014/main" id="{2DF2A783-30D4-4A89-A2D4-295FBCC53CC5}"/>
+                <a16:creationId xmlns:a16="http://schemas.microsoft.com/office/drawing/2014/main" id="{CC1245BF-FDAF-4061-9B42-C8E7F2C67307}"/>
               </a:ext>
             </a:extLst>
           </p:cNvPr>
@@ -7976,7 +8016,7 @@
           <p:cNvPr id="28" name="S2_InputHuman">
             <a:extLst xmlns:a="http://schemas.openxmlformats.org/drawingml/2006/main">
               <a:ext uri="{FF2B5EF4-FFF2-40B4-BE49-F238E27FC236}">
-                <a16:creationId xmlns:a16="http://schemas.microsoft.com/office/drawing/2014/main" id="{C8D65C0C-47E3-4989-9BFF-AA8BA60B01C0}"/>
+                <a16:creationId xmlns:a16="http://schemas.microsoft.com/office/drawing/2014/main" id="{92D7987F-C04D-4DB6-BD35-E281085C01E9}"/>
               </a:ext>
             </a:extLst>
           </p:cNvPr>
@@ -8011,7 +8051,7 @@
           <p:cNvPr id="29" name="S2_InputHumanTitle">
             <a:extLst xmlns:a="http://schemas.openxmlformats.org/drawingml/2006/main">
               <a:ext uri="{FF2B5EF4-FFF2-40B4-BE49-F238E27FC236}">
-                <a16:creationId xmlns:a16="http://schemas.microsoft.com/office/drawing/2014/main" id="{39AD8730-EE9F-4D92-9797-55FB854DB585}"/>
+                <a16:creationId xmlns:a16="http://schemas.microsoft.com/office/drawing/2014/main" id="{0C9DCF9B-075A-457C-A820-D8E1C59BE24F}"/>
               </a:ext>
             </a:extLst>
           </p:cNvPr>
@@ -8079,7 +8119,7 @@
           <p:cNvPr id="30" name="S2_InputHumanDetail">
             <a:extLst xmlns:a="http://schemas.openxmlformats.org/drawingml/2006/main">
               <a:ext uri="{FF2B5EF4-FFF2-40B4-BE49-F238E27FC236}">
-                <a16:creationId xmlns:a16="http://schemas.microsoft.com/office/drawing/2014/main" id="{1AF3A6FF-AA9F-4AAD-A659-AF2D3EBF5B51}"/>
+                <a16:creationId xmlns:a16="http://schemas.microsoft.com/office/drawing/2014/main" id="{A2303B53-FF5D-4391-A0D0-3E2A135AE7D9}"/>
               </a:ext>
             </a:extLst>
           </p:cNvPr>
@@ -8147,7 +8187,7 @@
           <p:cNvPr id="31" name="S2_ProcessHuman">
             <a:extLst xmlns:a="http://schemas.openxmlformats.org/drawingml/2006/main">
               <a:ext uri="{FF2B5EF4-FFF2-40B4-BE49-F238E27FC236}">
-                <a16:creationId xmlns:a16="http://schemas.microsoft.com/office/drawing/2014/main" id="{B0AB34F2-E9B9-4C6C-B133-4A035966DB7F}"/>
+                <a16:creationId xmlns:a16="http://schemas.microsoft.com/office/drawing/2014/main" id="{781C4438-C684-4943-9B0C-A515C8253109}"/>
               </a:ext>
             </a:extLst>
           </p:cNvPr>
@@ -8182,7 +8222,7 @@
           <p:cNvPr id="32" name="S2_ProcessHumanTitle">
             <a:extLst xmlns:a="http://schemas.openxmlformats.org/drawingml/2006/main">
               <a:ext uri="{FF2B5EF4-FFF2-40B4-BE49-F238E27FC236}">
-                <a16:creationId xmlns:a16="http://schemas.microsoft.com/office/drawing/2014/main" id="{BF45CA82-05F1-4EC1-BFB8-69692C0B17A6}"/>
+                <a16:creationId xmlns:a16="http://schemas.microsoft.com/office/drawing/2014/main" id="{C9FA600A-60E3-46B2-B2AD-06F08E6DABB5}"/>
               </a:ext>
             </a:extLst>
           </p:cNvPr>
@@ -8250,7 +8290,7 @@
           <p:cNvPr id="33" name="S2_ProcessHumanDetail">
             <a:extLst xmlns:a="http://schemas.openxmlformats.org/drawingml/2006/main">
               <a:ext uri="{FF2B5EF4-FFF2-40B4-BE49-F238E27FC236}">
-                <a16:creationId xmlns:a16="http://schemas.microsoft.com/office/drawing/2014/main" id="{5A66EE48-C056-4353-A589-6FB975D86B38}"/>
+                <a16:creationId xmlns:a16="http://schemas.microsoft.com/office/drawing/2014/main" id="{C02294FE-6BE4-4634-AD30-CAB023398800}"/>
               </a:ext>
             </a:extLst>
           </p:cNvPr>
@@ -8318,7 +8358,7 @@
           <p:cNvPr id="34" name="S2_OutputHuman">
             <a:extLst xmlns:a="http://schemas.openxmlformats.org/drawingml/2006/main">
               <a:ext uri="{FF2B5EF4-FFF2-40B4-BE49-F238E27FC236}">
-                <a16:creationId xmlns:a16="http://schemas.microsoft.com/office/drawing/2014/main" id="{CD6DCC9D-3087-4605-A274-8B96DED02346}"/>
+                <a16:creationId xmlns:a16="http://schemas.microsoft.com/office/drawing/2014/main" id="{3F530BAC-93FB-47FE-BDEC-EB10BBD8E11F}"/>
               </a:ext>
             </a:extLst>
           </p:cNvPr>
@@ -8353,7 +8393,7 @@
           <p:cNvPr id="35" name="S2_Gate9">
             <a:extLst xmlns:a="http://schemas.openxmlformats.org/drawingml/2006/main">
               <a:ext uri="{FF2B5EF4-FFF2-40B4-BE49-F238E27FC236}">
-                <a16:creationId xmlns:a16="http://schemas.microsoft.com/office/drawing/2014/main" id="{E6167413-40CE-40C6-9DBA-4806E3B58A33}"/>
+                <a16:creationId xmlns:a16="http://schemas.microsoft.com/office/drawing/2014/main" id="{0B064E81-FED8-4863-B6EB-8A6B2B911EF7}"/>
               </a:ext>
             </a:extLst>
           </p:cNvPr>
@@ -8428,7 +8468,7 @@
           <p:cNvPr id="36" name="S2_OutputHumanDetail">
             <a:extLst xmlns:a="http://schemas.openxmlformats.org/drawingml/2006/main">
               <a:ext uri="{FF2B5EF4-FFF2-40B4-BE49-F238E27FC236}">
-                <a16:creationId xmlns:a16="http://schemas.microsoft.com/office/drawing/2014/main" id="{FA410919-75C2-499B-9D45-F47472A9ED86}"/>
+                <a16:creationId xmlns:a16="http://schemas.microsoft.com/office/drawing/2014/main" id="{5DB59672-7836-4202-BE5D-4A65A6A0B8A1}"/>
               </a:ext>
             </a:extLst>
           </p:cNvPr>
@@ -8542,7 +8582,7 @@
           <p:cNvPr id="37" name="S2_AuthorityBand">
             <a:extLst xmlns:a="http://schemas.openxmlformats.org/drawingml/2006/main">
               <a:ext uri="{FF2B5EF4-FFF2-40B4-BE49-F238E27FC236}">
-                <a16:creationId xmlns:a16="http://schemas.microsoft.com/office/drawing/2014/main" id="{EEDE4166-4176-459A-8FB1-313E92188428}"/>
+                <a16:creationId xmlns:a16="http://schemas.microsoft.com/office/drawing/2014/main" id="{8220C37B-0DCA-4F55-92B5-41261998A76E}"/>
               </a:ext>
             </a:extLst>
           </p:cNvPr>
@@ -8577,7 +8617,7 @@
           <p:cNvPr id="38" name="S2_AuthorityAI">
             <a:extLst xmlns:a="http://schemas.openxmlformats.org/drawingml/2006/main">
               <a:ext uri="{FF2B5EF4-FFF2-40B4-BE49-F238E27FC236}">
-                <a16:creationId xmlns:a16="http://schemas.microsoft.com/office/drawing/2014/main" id="{F9BE096E-42CF-41F6-8CA8-6C8D79C00BFB}"/>
+                <a16:creationId xmlns:a16="http://schemas.microsoft.com/office/drawing/2014/main" id="{F954A4AF-03C6-49D2-9D35-F32BA3B47FFD}"/>
               </a:ext>
             </a:extLst>
           </p:cNvPr>
@@ -8645,7 +8685,7 @@
           <p:cNvPr id="39" name="S2_AuthorityPolicy">
             <a:extLst xmlns:a="http://schemas.openxmlformats.org/drawingml/2006/main">
               <a:ext uri="{FF2B5EF4-FFF2-40B4-BE49-F238E27FC236}">
-                <a16:creationId xmlns:a16="http://schemas.microsoft.com/office/drawing/2014/main" id="{CFD8E7D4-0807-4425-ABE7-C14981770ED3}"/>
+                <a16:creationId xmlns:a16="http://schemas.microsoft.com/office/drawing/2014/main" id="{84EE25C5-DF36-439E-ADBE-22AB2DAEF3D6}"/>
               </a:ext>
             </a:extLst>
           </p:cNvPr>
@@ -8713,7 +8753,7 @@
           <p:cNvPr id="40" name="S2_AuthorityHuman">
             <a:extLst xmlns:a="http://schemas.openxmlformats.org/drawingml/2006/main">
               <a:ext uri="{FF2B5EF4-FFF2-40B4-BE49-F238E27FC236}">
-                <a16:creationId xmlns:a16="http://schemas.microsoft.com/office/drawing/2014/main" id="{33C321E1-B874-4CBF-84E2-A2C8908D75A5}"/>
+                <a16:creationId xmlns:a16="http://schemas.microsoft.com/office/drawing/2014/main" id="{5DB53779-C45C-4859-AE7C-6782DF79A96E}"/>
               </a:ext>
             </a:extLst>
           </p:cNvPr>
@@ -8779,7 +8819,7 @@
     </p:spTree>
     <p:extLst>
       <p:ext uri="{BB962C8B-B14F-4D97-AF65-F5344CB8AC3E}">
-        <p14:creationId xmlns:p14="http://schemas.microsoft.com/office/powerpoint/2010/main" val="937618715"/>
+        <p14:creationId xmlns:p14="http://schemas.microsoft.com/office/powerpoint/2010/main" val="172275198"/>
       </p:ext>
     </p:extLst>
   </p:cSld>
@@ -8810,7 +8850,7 @@
           <p:cNvPr id="11" name="Slide_Title">
             <a:extLst xmlns:a="http://schemas.openxmlformats.org/drawingml/2006/main">
               <a:ext uri="{FF2B5EF4-FFF2-40B4-BE49-F238E27FC236}">
-                <a16:creationId xmlns:a16="http://schemas.microsoft.com/office/drawing/2014/main" id="{768069CE-C1D3-44FF-AADD-DD6043D8E84D}"/>
+                <a16:creationId xmlns:a16="http://schemas.microsoft.com/office/drawing/2014/main" id="{2C398CD6-9E9C-4980-A517-FC99B8BD7761}"/>
               </a:ext>
             </a:extLst>
           </p:cNvPr>
@@ -8878,7 +8918,7 @@
           <p:cNvPr id="2" name="Slide_Subtitle">
             <a:extLst xmlns:a="http://schemas.openxmlformats.org/drawingml/2006/main">
               <a:ext uri="{FF2B5EF4-FFF2-40B4-BE49-F238E27FC236}">
-                <a16:creationId xmlns:a16="http://schemas.microsoft.com/office/drawing/2014/main" id="{D5505B3C-2D0A-4543-A6E8-BFC93E78E957}"/>
+                <a16:creationId xmlns:a16="http://schemas.microsoft.com/office/drawing/2014/main" id="{6EEA0D0F-60BF-49E8-8D80-5053B9C75FEA}"/>
               </a:ext>
             </a:extLst>
           </p:cNvPr>
@@ -8946,7 +8986,7 @@
           <p:cNvPr id="3" name="S3_BeforeAfterTable">
             <a:extLst xmlns:a="http://schemas.openxmlformats.org/drawingml/2006/main">
               <a:ext uri="{FF2B5EF4-FFF2-40B4-BE49-F238E27FC236}">
-                <a16:creationId xmlns:a16="http://schemas.microsoft.com/office/drawing/2014/main" id="{D00D3CFD-EB04-4E2E-AD70-2C3433518990}"/>
+                <a16:creationId xmlns:a16="http://schemas.microsoft.com/office/drawing/2014/main" id="{2EEB0699-DA63-4E9E-B939-CB2A97451D22}"/>
               </a:ext>
             </a:extLst>
           </p:cNvPr>
@@ -10200,7 +10240,7 @@
           <p:cNvPr id="4" name="S3_ProtocolBand">
             <a:extLst xmlns:a="http://schemas.openxmlformats.org/drawingml/2006/main">
               <a:ext uri="{FF2B5EF4-FFF2-40B4-BE49-F238E27FC236}">
-                <a16:creationId xmlns:a16="http://schemas.microsoft.com/office/drawing/2014/main" id="{5288FE91-73B3-40F5-9BD3-DF7D41029989}"/>
+                <a16:creationId xmlns:a16="http://schemas.microsoft.com/office/drawing/2014/main" id="{C6CD0AE0-FAED-48BF-BA52-8AC12C15AFD0}"/>
               </a:ext>
             </a:extLst>
           </p:cNvPr>
@@ -10235,7 +10275,7 @@
           <p:cNvPr id="5" name="S3_ProtocolLabel">
             <a:extLst xmlns:a="http://schemas.openxmlformats.org/drawingml/2006/main">
               <a:ext uri="{FF2B5EF4-FFF2-40B4-BE49-F238E27FC236}">
-                <a16:creationId xmlns:a16="http://schemas.microsoft.com/office/drawing/2014/main" id="{1226A5EF-74D7-4A3A-99FB-E0FEF14632D8}"/>
+                <a16:creationId xmlns:a16="http://schemas.microsoft.com/office/drawing/2014/main" id="{DE61C124-9639-419A-8BCB-797B6D98C175}"/>
               </a:ext>
             </a:extLst>
           </p:cNvPr>
@@ -10303,7 +10343,7 @@
           <p:cNvPr id="6" name="S3_ProtocolLine1">
             <a:extLst xmlns:a="http://schemas.openxmlformats.org/drawingml/2006/main">
               <a:ext uri="{FF2B5EF4-FFF2-40B4-BE49-F238E27FC236}">
-                <a16:creationId xmlns:a16="http://schemas.microsoft.com/office/drawing/2014/main" id="{BD8474EC-6BED-46B3-A248-86C8DE5C638C}"/>
+                <a16:creationId xmlns:a16="http://schemas.microsoft.com/office/drawing/2014/main" id="{DFE33A3A-58B6-40D8-B383-27C34162A993}"/>
               </a:ext>
             </a:extLst>
           </p:cNvPr>
@@ -10371,7 +10411,7 @@
           <p:cNvPr id="7" name="S3_ProtocolLine2">
             <a:extLst xmlns:a="http://schemas.openxmlformats.org/drawingml/2006/main">
               <a:ext uri="{FF2B5EF4-FFF2-40B4-BE49-F238E27FC236}">
-                <a16:creationId xmlns:a16="http://schemas.microsoft.com/office/drawing/2014/main" id="{4B556B20-151A-45E1-9C55-1497E2BD2944}"/>
+                <a16:creationId xmlns:a16="http://schemas.microsoft.com/office/drawing/2014/main" id="{E68A5905-567B-4376-953B-A1C7186A9415}"/>
               </a:ext>
             </a:extLst>
           </p:cNvPr>
@@ -10439,7 +10479,7 @@
           <p:cNvPr id="8" name="S3_TechnicalStrip">
             <a:extLst xmlns:a="http://schemas.openxmlformats.org/drawingml/2006/main">
               <a:ext uri="{FF2B5EF4-FFF2-40B4-BE49-F238E27FC236}">
-                <a16:creationId xmlns:a16="http://schemas.microsoft.com/office/drawing/2014/main" id="{FCEAAF75-C67E-4456-81DA-06362E4C043D}"/>
+                <a16:creationId xmlns:a16="http://schemas.microsoft.com/office/drawing/2014/main" id="{1D18E901-A491-41C7-947C-8DC905AC0D95}"/>
               </a:ext>
             </a:extLst>
           </p:cNvPr>
@@ -10474,7 +10514,7 @@
           <p:cNvPr id="9" name="S3_TechnicalLabel">
             <a:extLst xmlns:a="http://schemas.openxmlformats.org/drawingml/2006/main">
               <a:ext uri="{FF2B5EF4-FFF2-40B4-BE49-F238E27FC236}">
-                <a16:creationId xmlns:a16="http://schemas.microsoft.com/office/drawing/2014/main" id="{D2F10A69-507C-4565-9B87-9BBE89321444}"/>
+                <a16:creationId xmlns:a16="http://schemas.microsoft.com/office/drawing/2014/main" id="{E43718BA-8852-4EA5-9E78-EC9F6D901CDF}"/>
               </a:ext>
             </a:extLst>
           </p:cNvPr>
@@ -10542,7 +10582,7 @@
           <p:cNvPr id="10" name="S3_TechnicalValues">
             <a:extLst xmlns:a="http://schemas.openxmlformats.org/drawingml/2006/main">
               <a:ext uri="{FF2B5EF4-FFF2-40B4-BE49-F238E27FC236}">
-                <a16:creationId xmlns:a16="http://schemas.microsoft.com/office/drawing/2014/main" id="{3EC6B68C-D9EF-431A-8F39-CC74E8B77AFA}"/>
+                <a16:creationId xmlns:a16="http://schemas.microsoft.com/office/drawing/2014/main" id="{24BD5339-7DDF-4987-AC8D-77436FD25143}"/>
               </a:ext>
             </a:extLst>
           </p:cNvPr>
@@ -10608,7 +10648,7 @@
     </p:spTree>
     <p:extLst>
       <p:ext uri="{BB962C8B-B14F-4D97-AF65-F5344CB8AC3E}">
-        <p14:creationId xmlns:p14="http://schemas.microsoft.com/office/powerpoint/2010/main" val="1468386153"/>
+        <p14:creationId xmlns:p14="http://schemas.microsoft.com/office/powerpoint/2010/main" val="145444809"/>
       </p:ext>
     </p:extLst>
   </p:cSld>
@@ -10636,10 +10676,10 @@
       </p:grpSpPr>
       <p:sp>
         <p:nvSpPr>
-          <p:cNvPr id="39" name="Slide_Title">
-            <a:extLst xmlns:a="http://schemas.openxmlformats.org/drawingml/2006/main">
-              <a:ext uri="{FF2B5EF4-FFF2-40B4-BE49-F238E27FC236}">
-                <a16:creationId xmlns:a16="http://schemas.microsoft.com/office/drawing/2014/main" id="{F369627E-A405-4256-9943-3184D143A495}"/>
+          <p:cNvPr id="40" name="Slide_Title">
+            <a:extLst xmlns:a="http://schemas.openxmlformats.org/drawingml/2006/main">
+              <a:ext uri="{FF2B5EF4-FFF2-40B4-BE49-F238E27FC236}">
+                <a16:creationId xmlns:a16="http://schemas.microsoft.com/office/drawing/2014/main" id="{65912BAC-E7AF-49B1-8EDA-08D65E455BAC}"/>
               </a:ext>
             </a:extLst>
           </p:cNvPr>
@@ -10697,7 +10737,7 @@
                 <a:ea typeface="Segoe UI"/>
                 <a:cs typeface="Segoe UI"/>
               </a:rPr>
-              <a:t>Kiến trúc triển khai và phạm vi evidence</a:t>
+              <a:t>Kiến trúc, ranh giới thực thi và phạm vi evidence</a:t>
             </a:r>
           </a:p>
         </p:txBody>
@@ -10707,7 +10747,7 @@
           <p:cNvPr id="2" name="Slide_Subtitle">
             <a:extLst xmlns:a="http://schemas.openxmlformats.org/drawingml/2006/main">
               <a:ext uri="{FF2B5EF4-FFF2-40B4-BE49-F238E27FC236}">
-                <a16:creationId xmlns:a16="http://schemas.microsoft.com/office/drawing/2014/main" id="{451F509F-516A-4EC1-9E63-850A865D2C8C}"/>
+                <a16:creationId xmlns:a16="http://schemas.microsoft.com/office/drawing/2014/main" id="{C8575782-CC2E-47F4-BB67-AFFB853D9BB6}"/>
               </a:ext>
             </a:extLst>
           </p:cNvPr>
@@ -10765,7 +10805,7 @@
                 <a:ea typeface="Segoe UI"/>
                 <a:cs typeface="Segoe UI"/>
               </a:rPr>
-              <a:t>Nhãn CHẠY THẬT hoặc MÔ PHỎNG / TEST nằm trực tiếp trên từng khối.</a:t>
+              <a:t>Mỗi khối ghi rõ phần đang chạy, quyền của model và phần còn mô phỏng / test.</a:t>
             </a:r>
           </a:p>
         </p:txBody>
@@ -10775,7 +10815,7 @@
           <p:cNvPr id="3" name="S4_Layer_1">
             <a:extLst xmlns:a="http://schemas.openxmlformats.org/drawingml/2006/main">
               <a:ext uri="{FF2B5EF4-FFF2-40B4-BE49-F238E27FC236}">
-                <a16:creationId xmlns:a16="http://schemas.microsoft.com/office/drawing/2014/main" id="{A7E4213F-B54D-4B92-A0CF-180EB1B06BB5}"/>
+                <a16:creationId xmlns:a16="http://schemas.microsoft.com/office/drawing/2014/main" id="{565E9AE7-3F31-479C-AA20-F64DD8F38AD2}"/>
               </a:ext>
             </a:extLst>
           </p:cNvPr>
@@ -10810,7 +10850,7 @@
           <p:cNvPr id="4" name="S4_LiveBadge_1">
             <a:extLst xmlns:a="http://schemas.openxmlformats.org/drawingml/2006/main">
               <a:ext uri="{FF2B5EF4-FFF2-40B4-BE49-F238E27FC236}">
-                <a16:creationId xmlns:a16="http://schemas.microsoft.com/office/drawing/2014/main" id="{B07C72AD-B5DB-415F-8B6C-8973630B5E36}"/>
+                <a16:creationId xmlns:a16="http://schemas.microsoft.com/office/drawing/2014/main" id="{3F239E59-424B-4D76-A626-F0405A7E2994}"/>
               </a:ext>
             </a:extLst>
           </p:cNvPr>
@@ -10885,7 +10925,7 @@
           <p:cNvPr id="5" name="S4_LayerLabel_1">
             <a:extLst xmlns:a="http://schemas.openxmlformats.org/drawingml/2006/main">
               <a:ext uri="{FF2B5EF4-FFF2-40B4-BE49-F238E27FC236}">
-                <a16:creationId xmlns:a16="http://schemas.microsoft.com/office/drawing/2014/main" id="{DF3D1764-99C6-4AC2-A86A-009E68ED0859}"/>
+                <a16:creationId xmlns:a16="http://schemas.microsoft.com/office/drawing/2014/main" id="{233227CF-D1B5-4AF6-B391-7E4D191A2FCF}"/>
               </a:ext>
             </a:extLst>
           </p:cNvPr>
@@ -10953,19 +10993,19 @@
           <p:cNvPr id="6" name="S4_LayerText_1">
             <a:extLst xmlns:a="http://schemas.openxmlformats.org/drawingml/2006/main">
               <a:ext uri="{FF2B5EF4-FFF2-40B4-BE49-F238E27FC236}">
-                <a16:creationId xmlns:a16="http://schemas.microsoft.com/office/drawing/2014/main" id="{EFBE5DC4-D26A-46CB-A472-DBB04A285647}"/>
-              </a:ext>
-            </a:extLst>
-          </p:cNvPr>
-          <p:cNvSpPr>
-            <a:spLocks xmlns:a="http://schemas.openxmlformats.org/drawingml/2006/main" noGrp="1"/>
-          </p:cNvSpPr>
-          <p:nvPr/>
-        </p:nvSpPr>
-        <p:spPr>
-          <a:xfrm xmlns:a="http://schemas.openxmlformats.org/drawingml/2006/main">
-            <a:off x="1962150" y="1809750"/>
-            <a:ext cx="5715000" cy="228600"/>
+                <a16:creationId xmlns:a16="http://schemas.microsoft.com/office/drawing/2014/main" id="{D9F61BA1-87AE-4592-9217-0202FB43BCDC}"/>
+              </a:ext>
+            </a:extLst>
+          </p:cNvPr>
+          <p:cNvSpPr>
+            <a:spLocks xmlns:a="http://schemas.openxmlformats.org/drawingml/2006/main" noGrp="1"/>
+          </p:cNvSpPr>
+          <p:nvPr/>
+        </p:nvSpPr>
+        <p:spPr>
+          <a:xfrm xmlns:a="http://schemas.openxmlformats.org/drawingml/2006/main">
+            <a:off x="1962150" y="1762125"/>
+            <a:ext cx="5715000" cy="323850"/>
           </a:xfrm>
           <a:prstGeom xmlns:a="http://schemas.openxmlformats.org/drawingml/2006/main" prst="rect">
             <a:avLst/>
@@ -11021,7 +11061,7 @@
           <p:cNvPr id="7" name="S4_LayerConnector_1">
             <a:extLst xmlns:a="http://schemas.openxmlformats.org/drawingml/2006/main">
               <a:ext uri="{FF2B5EF4-FFF2-40B4-BE49-F238E27FC236}">
-                <a16:creationId xmlns:a16="http://schemas.microsoft.com/office/drawing/2014/main" id="{AF4550A0-6325-43DD-A04A-55FB7B84E76A}"/>
+                <a16:creationId xmlns:a16="http://schemas.microsoft.com/office/drawing/2014/main" id="{3E4BED53-001A-496F-911D-556710C80156}"/>
               </a:ext>
             </a:extLst>
           </p:cNvPr>
@@ -11052,7 +11092,7 @@
           <p:cNvPr id="8" name="S4_Layer_2">
             <a:extLst xmlns:a="http://schemas.openxmlformats.org/drawingml/2006/main">
               <a:ext uri="{FF2B5EF4-FFF2-40B4-BE49-F238E27FC236}">
-                <a16:creationId xmlns:a16="http://schemas.microsoft.com/office/drawing/2014/main" id="{E451F622-F6A2-46B1-AE43-25E913C66B58}"/>
+                <a16:creationId xmlns:a16="http://schemas.microsoft.com/office/drawing/2014/main" id="{5DE2A25B-3185-4904-8FEE-C8C37E7E7E7D}"/>
               </a:ext>
             </a:extLst>
           </p:cNvPr>
@@ -11087,7 +11127,7 @@
           <p:cNvPr id="9" name="S4_LiveBadge_2">
             <a:extLst xmlns:a="http://schemas.openxmlformats.org/drawingml/2006/main">
               <a:ext uri="{FF2B5EF4-FFF2-40B4-BE49-F238E27FC236}">
-                <a16:creationId xmlns:a16="http://schemas.microsoft.com/office/drawing/2014/main" id="{4BF05781-E45A-4E1B-A65B-192B93C2451B}"/>
+                <a16:creationId xmlns:a16="http://schemas.microsoft.com/office/drawing/2014/main" id="{4B9F1DD6-7F68-47C0-8854-FB5525FA7752}"/>
               </a:ext>
             </a:extLst>
           </p:cNvPr>
@@ -11162,7 +11202,7 @@
           <p:cNvPr id="10" name="S4_LayerLabel_2">
             <a:extLst xmlns:a="http://schemas.openxmlformats.org/drawingml/2006/main">
               <a:ext uri="{FF2B5EF4-FFF2-40B4-BE49-F238E27FC236}">
-                <a16:creationId xmlns:a16="http://schemas.microsoft.com/office/drawing/2014/main" id="{ED04D858-ADC1-4EA7-9BBA-07205550AE35}"/>
+                <a16:creationId xmlns:a16="http://schemas.microsoft.com/office/drawing/2014/main" id="{F1933673-D90D-4CE6-9EE8-874F121AA170}"/>
               </a:ext>
             </a:extLst>
           </p:cNvPr>
@@ -11230,19 +11270,19 @@
           <p:cNvPr id="11" name="S4_LayerText_2">
             <a:extLst xmlns:a="http://schemas.openxmlformats.org/drawingml/2006/main">
               <a:ext uri="{FF2B5EF4-FFF2-40B4-BE49-F238E27FC236}">
-                <a16:creationId xmlns:a16="http://schemas.microsoft.com/office/drawing/2014/main" id="{4CA0F23E-2493-4DDF-A650-ECF931085DC0}"/>
-              </a:ext>
-            </a:extLst>
-          </p:cNvPr>
-          <p:cNvSpPr>
-            <a:spLocks xmlns:a="http://schemas.openxmlformats.org/drawingml/2006/main" noGrp="1"/>
-          </p:cNvSpPr>
-          <p:nvPr/>
-        </p:nvSpPr>
-        <p:spPr>
-          <a:xfrm xmlns:a="http://schemas.openxmlformats.org/drawingml/2006/main">
-            <a:off x="1962150" y="2686050"/>
-            <a:ext cx="5715000" cy="228600"/>
+                <a16:creationId xmlns:a16="http://schemas.microsoft.com/office/drawing/2014/main" id="{5E3AAA0E-B67A-4F64-B96D-9A6CA910BE02}"/>
+              </a:ext>
+            </a:extLst>
+          </p:cNvPr>
+          <p:cNvSpPr>
+            <a:spLocks xmlns:a="http://schemas.openxmlformats.org/drawingml/2006/main" noGrp="1"/>
+          </p:cNvSpPr>
+          <p:nvPr/>
+        </p:nvSpPr>
+        <p:spPr>
+          <a:xfrm xmlns:a="http://schemas.openxmlformats.org/drawingml/2006/main">
+            <a:off x="1962150" y="2638425"/>
+            <a:ext cx="5715000" cy="323850"/>
           </a:xfrm>
           <a:prstGeom xmlns:a="http://schemas.openxmlformats.org/drawingml/2006/main" prst="rect">
             <a:avLst/>
@@ -11298,7 +11338,7 @@
           <p:cNvPr id="12" name="S4_LayerConnector_2">
             <a:extLst xmlns:a="http://schemas.openxmlformats.org/drawingml/2006/main">
               <a:ext uri="{FF2B5EF4-FFF2-40B4-BE49-F238E27FC236}">
-                <a16:creationId xmlns:a16="http://schemas.microsoft.com/office/drawing/2014/main" id="{570078C5-D243-4652-A9CC-C4410342DE18}"/>
+                <a16:creationId xmlns:a16="http://schemas.microsoft.com/office/drawing/2014/main" id="{C6AB7245-5213-406F-A1C8-DD11FB568638}"/>
               </a:ext>
             </a:extLst>
           </p:cNvPr>
@@ -11329,7 +11369,7 @@
           <p:cNvPr id="13" name="S4_Layer_3">
             <a:extLst xmlns:a="http://schemas.openxmlformats.org/drawingml/2006/main">
               <a:ext uri="{FF2B5EF4-FFF2-40B4-BE49-F238E27FC236}">
-                <a16:creationId xmlns:a16="http://schemas.microsoft.com/office/drawing/2014/main" id="{0476C54E-637B-430A-BB57-183B7168FFCA}"/>
+                <a16:creationId xmlns:a16="http://schemas.microsoft.com/office/drawing/2014/main" id="{2E4F629E-5457-495E-A188-EC815B2B023D}"/>
               </a:ext>
             </a:extLst>
           </p:cNvPr>
@@ -11364,7 +11404,7 @@
           <p:cNvPr id="14" name="S4_LiveBadge_3">
             <a:extLst xmlns:a="http://schemas.openxmlformats.org/drawingml/2006/main">
               <a:ext uri="{FF2B5EF4-FFF2-40B4-BE49-F238E27FC236}">
-                <a16:creationId xmlns:a16="http://schemas.microsoft.com/office/drawing/2014/main" id="{84EF7B91-CFDD-4747-A66F-67C076B96CC4}"/>
+                <a16:creationId xmlns:a16="http://schemas.microsoft.com/office/drawing/2014/main" id="{61CFBE69-FC83-4560-9D3C-86C2CBBD766E}"/>
               </a:ext>
             </a:extLst>
           </p:cNvPr>
@@ -11439,7 +11479,7 @@
           <p:cNvPr id="15" name="S4_LayerLabel_3">
             <a:extLst xmlns:a="http://schemas.openxmlformats.org/drawingml/2006/main">
               <a:ext uri="{FF2B5EF4-FFF2-40B4-BE49-F238E27FC236}">
-                <a16:creationId xmlns:a16="http://schemas.microsoft.com/office/drawing/2014/main" id="{79FCD3ED-E94D-41AD-8C1F-74E73F2D8B4F}"/>
+                <a16:creationId xmlns:a16="http://schemas.microsoft.com/office/drawing/2014/main" id="{27745A52-58E1-493F-A01E-93FE98570E79}"/>
               </a:ext>
             </a:extLst>
           </p:cNvPr>
@@ -11507,19 +11547,19 @@
           <p:cNvPr id="16" name="S4_LayerText_3">
             <a:extLst xmlns:a="http://schemas.openxmlformats.org/drawingml/2006/main">
               <a:ext uri="{FF2B5EF4-FFF2-40B4-BE49-F238E27FC236}">
-                <a16:creationId xmlns:a16="http://schemas.microsoft.com/office/drawing/2014/main" id="{F7183442-BE18-4142-9035-562BDA0AB2F8}"/>
-              </a:ext>
-            </a:extLst>
-          </p:cNvPr>
-          <p:cNvSpPr>
-            <a:spLocks xmlns:a="http://schemas.openxmlformats.org/drawingml/2006/main" noGrp="1"/>
-          </p:cNvSpPr>
-          <p:nvPr/>
-        </p:nvSpPr>
-        <p:spPr>
-          <a:xfrm xmlns:a="http://schemas.openxmlformats.org/drawingml/2006/main">
-            <a:off x="1962150" y="3562350"/>
-            <a:ext cx="5715000" cy="228600"/>
+                <a16:creationId xmlns:a16="http://schemas.microsoft.com/office/drawing/2014/main" id="{5116EC11-A3E4-491F-BD8A-63C759A5D9BD}"/>
+              </a:ext>
+            </a:extLst>
+          </p:cNvPr>
+          <p:cNvSpPr>
+            <a:spLocks xmlns:a="http://schemas.openxmlformats.org/drawingml/2006/main" noGrp="1"/>
+          </p:cNvSpPr>
+          <p:nvPr/>
+        </p:nvSpPr>
+        <p:spPr>
+          <a:xfrm xmlns:a="http://schemas.openxmlformats.org/drawingml/2006/main">
+            <a:off x="1962150" y="3514725"/>
+            <a:ext cx="5715000" cy="323850"/>
           </a:xfrm>
           <a:prstGeom xmlns:a="http://schemas.openxmlformats.org/drawingml/2006/main" prst="rect">
             <a:avLst/>
@@ -11535,7 +11575,7 @@
           </a:bodyPr>
           <a:lstStyle xmlns:a="http://schemas.openxmlformats.org/drawingml/2006/main">
             <a:defPPr algn="l">
-              <a:defRPr sz="1050" b="1">
+              <a:defRPr sz="900" b="1">
                 <a:solidFill>
                   <a:srgbClr val="F4F7FB"/>
                 </a:solidFill>
@@ -11547,7 +11587,7 @@
           </a:lstStyle>
           <a:p xmlns:a="http://schemas.openxmlformats.org/drawingml/2006/main">
             <a:pPr algn="l">
-              <a:defRPr sz="1050" b="1">
+              <a:defRPr sz="900" b="1">
                 <a:solidFill>
                   <a:srgbClr val="F4F7FB"/>
                 </a:solidFill>
@@ -11557,7 +11597,7 @@
               </a:defRPr>
             </a:pPr>
             <a:r>
-              <a:rPr sz="1050" b="1">
+              <a:rPr sz="900" b="1">
                 <a:solidFill>
                   <a:srgbClr val="F4F7FB"/>
                 </a:solidFill>
@@ -11565,7 +11605,30 @@
                 <a:ea typeface="Segoe UI"/>
                 <a:cs typeface="Segoe UI"/>
               </a:rPr>
-              <a:t>OpenRouter • Qwen3.8 Flash • Schema → DTO → semantic → repair ≤ 1</a:t>
+              <a:t>OpenRouter • Qwen3.8 Flash • image → DTO • không tool / DB write</a:t>
+            </a:r>
+          </a:p>
+          <a:p xmlns:a="http://schemas.openxmlformats.org/drawingml/2006/main">
+            <a:pPr algn="l">
+              <a:defRPr sz="900" b="1">
+                <a:solidFill>
+                  <a:srgbClr val="F4F7FB"/>
+                </a:solidFill>
+                <a:latin typeface="Segoe UI"/>
+                <a:ea typeface="Segoe UI"/>
+                <a:cs typeface="Segoe UI"/>
+              </a:defRPr>
+            </a:pPr>
+            <a:r>
+              <a:rPr sz="900" b="1">
+                <a:solidFill>
+                  <a:srgbClr val="F4F7FB"/>
+                </a:solidFill>
+                <a:latin typeface="Segoe UI"/>
+                <a:ea typeface="Segoe UI"/>
+                <a:cs typeface="Segoe UI"/>
+              </a:rPr>
+              <a:t>Schema • semantic validation • repair ≤ 1</a:t>
             </a:r>
           </a:p>
         </p:txBody>
@@ -11575,7 +11638,7 @@
           <p:cNvPr id="17" name="S4_LayerConnector_3">
             <a:extLst xmlns:a="http://schemas.openxmlformats.org/drawingml/2006/main">
               <a:ext uri="{FF2B5EF4-FFF2-40B4-BE49-F238E27FC236}">
-                <a16:creationId xmlns:a16="http://schemas.microsoft.com/office/drawing/2014/main" id="{98057916-CB30-45E2-B0F8-B2601FBADE25}"/>
+                <a16:creationId xmlns:a16="http://schemas.microsoft.com/office/drawing/2014/main" id="{10917903-E1CE-4858-AA6F-FC7577258FCE}"/>
               </a:ext>
             </a:extLst>
           </p:cNvPr>
@@ -11606,7 +11669,7 @@
           <p:cNvPr id="18" name="S4_Layer_4">
             <a:extLst xmlns:a="http://schemas.openxmlformats.org/drawingml/2006/main">
               <a:ext uri="{FF2B5EF4-FFF2-40B4-BE49-F238E27FC236}">
-                <a16:creationId xmlns:a16="http://schemas.microsoft.com/office/drawing/2014/main" id="{B35F2A51-6E0F-4EBD-A3F4-AB4C675C1130}"/>
+                <a16:creationId xmlns:a16="http://schemas.microsoft.com/office/drawing/2014/main" id="{C5093956-6B80-486D-ACBC-8A9815A6F51A}"/>
               </a:ext>
             </a:extLst>
           </p:cNvPr>
@@ -11641,7 +11704,7 @@
           <p:cNvPr id="19" name="S4_LiveBadge_4">
             <a:extLst xmlns:a="http://schemas.openxmlformats.org/drawingml/2006/main">
               <a:ext uri="{FF2B5EF4-FFF2-40B4-BE49-F238E27FC236}">
-                <a16:creationId xmlns:a16="http://schemas.microsoft.com/office/drawing/2014/main" id="{8BFA26CA-7C71-4B06-9A9E-3D92F51F0662}"/>
+                <a16:creationId xmlns:a16="http://schemas.microsoft.com/office/drawing/2014/main" id="{6A68C435-19BD-4EEA-909B-F9F5621F7664}"/>
               </a:ext>
             </a:extLst>
           </p:cNvPr>
@@ -11716,7 +11779,7 @@
           <p:cNvPr id="20" name="S4_LayerLabel_4">
             <a:extLst xmlns:a="http://schemas.openxmlformats.org/drawingml/2006/main">
               <a:ext uri="{FF2B5EF4-FFF2-40B4-BE49-F238E27FC236}">
-                <a16:creationId xmlns:a16="http://schemas.microsoft.com/office/drawing/2014/main" id="{80494153-ED77-4E1F-9A6C-16BF43606E58}"/>
+                <a16:creationId xmlns:a16="http://schemas.microsoft.com/office/drawing/2014/main" id="{C3AF66B6-ABAE-4B32-BB76-E7BFF530E479}"/>
               </a:ext>
             </a:extLst>
           </p:cNvPr>
@@ -11784,19 +11847,19 @@
           <p:cNvPr id="21" name="S4_LayerText_4">
             <a:extLst xmlns:a="http://schemas.openxmlformats.org/drawingml/2006/main">
               <a:ext uri="{FF2B5EF4-FFF2-40B4-BE49-F238E27FC236}">
-                <a16:creationId xmlns:a16="http://schemas.microsoft.com/office/drawing/2014/main" id="{70B65F5C-3B4B-4DA1-A913-11D008995671}"/>
-              </a:ext>
-            </a:extLst>
-          </p:cNvPr>
-          <p:cNvSpPr>
-            <a:spLocks xmlns:a="http://schemas.openxmlformats.org/drawingml/2006/main" noGrp="1"/>
-          </p:cNvSpPr>
-          <p:nvPr/>
-        </p:nvSpPr>
-        <p:spPr>
-          <a:xfrm xmlns:a="http://schemas.openxmlformats.org/drawingml/2006/main">
-            <a:off x="1962150" y="4438650"/>
-            <a:ext cx="5715000" cy="228600"/>
+                <a16:creationId xmlns:a16="http://schemas.microsoft.com/office/drawing/2014/main" id="{D5835FEF-3F96-46A3-A934-7D942C2DDE9A}"/>
+              </a:ext>
+            </a:extLst>
+          </p:cNvPr>
+          <p:cNvSpPr>
+            <a:spLocks xmlns:a="http://schemas.openxmlformats.org/drawingml/2006/main" noGrp="1"/>
+          </p:cNvSpPr>
+          <p:nvPr/>
+        </p:nvSpPr>
+        <p:spPr>
+          <a:xfrm xmlns:a="http://schemas.openxmlformats.org/drawingml/2006/main">
+            <a:off x="1962150" y="4391025"/>
+            <a:ext cx="5715000" cy="323850"/>
           </a:xfrm>
           <a:prstGeom xmlns:a="http://schemas.openxmlformats.org/drawingml/2006/main" prst="rect">
             <a:avLst/>
@@ -11852,7 +11915,7 @@
           <p:cNvPr id="22" name="S4_TestBoundary">
             <a:extLst xmlns:a="http://schemas.openxmlformats.org/drawingml/2006/main">
               <a:ext uri="{FF2B5EF4-FFF2-40B4-BE49-F238E27FC236}">
-                <a16:creationId xmlns:a16="http://schemas.microsoft.com/office/drawing/2014/main" id="{2DC7D051-B04F-416E-83BA-9A575E8C3C83}"/>
+                <a16:creationId xmlns:a16="http://schemas.microsoft.com/office/drawing/2014/main" id="{9B79BE63-14F8-4E3F-BECA-EC6383440668}"/>
               </a:ext>
             </a:extLst>
           </p:cNvPr>
@@ -11887,7 +11950,7 @@
           <p:cNvPr id="23" name="S4_TestTitle">
             <a:extLst xmlns:a="http://schemas.openxmlformats.org/drawingml/2006/main">
               <a:ext uri="{FF2B5EF4-FFF2-40B4-BE49-F238E27FC236}">
-                <a16:creationId xmlns:a16="http://schemas.microsoft.com/office/drawing/2014/main" id="{B0DBC4F5-4F2A-499A-B048-2B0DB1CCFB0A}"/>
+                <a16:creationId xmlns:a16="http://schemas.microsoft.com/office/drawing/2014/main" id="{AB64DD76-ADB2-4295-8066-CCD88FB39F0D}"/>
               </a:ext>
             </a:extLst>
           </p:cNvPr>
@@ -11955,7 +12018,7 @@
           <p:cNvPr id="24" name="S4_TestItem_1">
             <a:extLst xmlns:a="http://schemas.openxmlformats.org/drawingml/2006/main">
               <a:ext uri="{FF2B5EF4-FFF2-40B4-BE49-F238E27FC236}">
-                <a16:creationId xmlns:a16="http://schemas.microsoft.com/office/drawing/2014/main" id="{5884FF3D-B49E-4475-B204-3FF9EA41E26A}"/>
+                <a16:creationId xmlns:a16="http://schemas.microsoft.com/office/drawing/2014/main" id="{C4AACDA9-1354-4857-B5D4-B1CF3B4B3D15}"/>
               </a:ext>
             </a:extLst>
           </p:cNvPr>
@@ -11990,7 +12053,7 @@
           <p:cNvPr id="25" name="S4_TestBadge_1">
             <a:extLst xmlns:a="http://schemas.openxmlformats.org/drawingml/2006/main">
               <a:ext uri="{FF2B5EF4-FFF2-40B4-BE49-F238E27FC236}">
-                <a16:creationId xmlns:a16="http://schemas.microsoft.com/office/drawing/2014/main" id="{98E56E39-5159-4CC7-8B9E-D939854C0118}"/>
+                <a16:creationId xmlns:a16="http://schemas.microsoft.com/office/drawing/2014/main" id="{F916D631-7C73-4A7D-AAA1-F94F854E8818}"/>
               </a:ext>
             </a:extLst>
           </p:cNvPr>
@@ -12065,7 +12128,7 @@
           <p:cNvPr id="26" name="S4_TestLabel_1">
             <a:extLst xmlns:a="http://schemas.openxmlformats.org/drawingml/2006/main">
               <a:ext uri="{FF2B5EF4-FFF2-40B4-BE49-F238E27FC236}">
-                <a16:creationId xmlns:a16="http://schemas.microsoft.com/office/drawing/2014/main" id="{5B1F1140-1FA6-42DF-9FCE-46D31AF929E6}"/>
+                <a16:creationId xmlns:a16="http://schemas.microsoft.com/office/drawing/2014/main" id="{74AA5567-51C7-433C-BD89-27CB08F5C471}"/>
               </a:ext>
             </a:extLst>
           </p:cNvPr>
@@ -12133,7 +12196,7 @@
           <p:cNvPr id="27" name="S4_TestDetail_1">
             <a:extLst xmlns:a="http://schemas.openxmlformats.org/drawingml/2006/main">
               <a:ext uri="{FF2B5EF4-FFF2-40B4-BE49-F238E27FC236}">
-                <a16:creationId xmlns:a16="http://schemas.microsoft.com/office/drawing/2014/main" id="{9E9F4E61-F59D-4AA3-BDDC-DD7A7C7BD7D5}"/>
+                <a16:creationId xmlns:a16="http://schemas.microsoft.com/office/drawing/2014/main" id="{73F0511C-25B9-494D-A058-0AD1AFEDA592}"/>
               </a:ext>
             </a:extLst>
           </p:cNvPr>
@@ -12201,7 +12264,7 @@
           <p:cNvPr id="28" name="S4_TestItem_2">
             <a:extLst xmlns:a="http://schemas.openxmlformats.org/drawingml/2006/main">
               <a:ext uri="{FF2B5EF4-FFF2-40B4-BE49-F238E27FC236}">
-                <a16:creationId xmlns:a16="http://schemas.microsoft.com/office/drawing/2014/main" id="{273EDD10-DF9B-4DF9-BBB1-A9D64F91EFFC}"/>
+                <a16:creationId xmlns:a16="http://schemas.microsoft.com/office/drawing/2014/main" id="{FB64E67A-9B6D-4C39-A918-008F10BDE361}"/>
               </a:ext>
             </a:extLst>
           </p:cNvPr>
@@ -12236,7 +12299,7 @@
           <p:cNvPr id="29" name="S4_TestBadge_2">
             <a:extLst xmlns:a="http://schemas.openxmlformats.org/drawingml/2006/main">
               <a:ext uri="{FF2B5EF4-FFF2-40B4-BE49-F238E27FC236}">
-                <a16:creationId xmlns:a16="http://schemas.microsoft.com/office/drawing/2014/main" id="{5245BBEA-6F50-4CB8-9FAA-FF867D6A2EC4}"/>
+                <a16:creationId xmlns:a16="http://schemas.microsoft.com/office/drawing/2014/main" id="{C3C027CD-46A0-4619-8395-712DF063F506}"/>
               </a:ext>
             </a:extLst>
           </p:cNvPr>
@@ -12311,7 +12374,7 @@
           <p:cNvPr id="30" name="S4_TestLabel_2">
             <a:extLst xmlns:a="http://schemas.openxmlformats.org/drawingml/2006/main">
               <a:ext uri="{FF2B5EF4-FFF2-40B4-BE49-F238E27FC236}">
-                <a16:creationId xmlns:a16="http://schemas.microsoft.com/office/drawing/2014/main" id="{56177B48-A4FC-4B14-A95F-C6B43F9BF56A}"/>
+                <a16:creationId xmlns:a16="http://schemas.microsoft.com/office/drawing/2014/main" id="{980BFF09-6D5D-475D-9763-19BA21848C6F}"/>
               </a:ext>
             </a:extLst>
           </p:cNvPr>
@@ -12379,7 +12442,7 @@
           <p:cNvPr id="31" name="S4_TestDetail_2">
             <a:extLst xmlns:a="http://schemas.openxmlformats.org/drawingml/2006/main">
               <a:ext uri="{FF2B5EF4-FFF2-40B4-BE49-F238E27FC236}">
-                <a16:creationId xmlns:a16="http://schemas.microsoft.com/office/drawing/2014/main" id="{75DD59B3-BFFD-41DB-94D7-A4A9BC1BEE06}"/>
+                <a16:creationId xmlns:a16="http://schemas.microsoft.com/office/drawing/2014/main" id="{20920BEC-7178-445A-BB6D-A0FAC039851C}"/>
               </a:ext>
             </a:extLst>
           </p:cNvPr>
@@ -12447,7 +12510,7 @@
           <p:cNvPr id="32" name="S4_TestItem_3">
             <a:extLst xmlns:a="http://schemas.openxmlformats.org/drawingml/2006/main">
               <a:ext uri="{FF2B5EF4-FFF2-40B4-BE49-F238E27FC236}">
-                <a16:creationId xmlns:a16="http://schemas.microsoft.com/office/drawing/2014/main" id="{1F9F4C1D-B7AD-4768-8AEB-3E27B5D4315B}"/>
+                <a16:creationId xmlns:a16="http://schemas.microsoft.com/office/drawing/2014/main" id="{DCC4FC77-3E28-4965-AF90-2A793F31D0F0}"/>
               </a:ext>
             </a:extLst>
           </p:cNvPr>
@@ -12482,7 +12545,7 @@
           <p:cNvPr id="33" name="S4_TestBadge_3">
             <a:extLst xmlns:a="http://schemas.openxmlformats.org/drawingml/2006/main">
               <a:ext uri="{FF2B5EF4-FFF2-40B4-BE49-F238E27FC236}">
-                <a16:creationId xmlns:a16="http://schemas.microsoft.com/office/drawing/2014/main" id="{08F259A7-8E0F-4B2A-B81E-394D1580AF27}"/>
+                <a16:creationId xmlns:a16="http://schemas.microsoft.com/office/drawing/2014/main" id="{FA1B6845-1349-41F3-B6B8-F49B93668962}"/>
               </a:ext>
             </a:extLst>
           </p:cNvPr>
@@ -12557,7 +12620,7 @@
           <p:cNvPr id="34" name="S4_TestLabel_3">
             <a:extLst xmlns:a="http://schemas.openxmlformats.org/drawingml/2006/main">
               <a:ext uri="{FF2B5EF4-FFF2-40B4-BE49-F238E27FC236}">
-                <a16:creationId xmlns:a16="http://schemas.microsoft.com/office/drawing/2014/main" id="{54B7EA5C-3C51-462D-A6C0-C0D492276426}"/>
+                <a16:creationId xmlns:a16="http://schemas.microsoft.com/office/drawing/2014/main" id="{6B7CD6A3-1694-4B67-BDA4-DBF9B12B9F6A}"/>
               </a:ext>
             </a:extLst>
           </p:cNvPr>
@@ -12625,7 +12688,7 @@
           <p:cNvPr id="35" name="S4_TestDetail_3">
             <a:extLst xmlns:a="http://schemas.openxmlformats.org/drawingml/2006/main">
               <a:ext uri="{FF2B5EF4-FFF2-40B4-BE49-F238E27FC236}">
-                <a16:creationId xmlns:a16="http://schemas.microsoft.com/office/drawing/2014/main" id="{F6A38BDB-3887-4F83-8555-0A665B0FCDA5}"/>
+                <a16:creationId xmlns:a16="http://schemas.microsoft.com/office/drawing/2014/main" id="{E6BFFDA2-65A0-4379-99FE-0B6A49E5A6D8}"/>
               </a:ext>
             </a:extLst>
           </p:cNvPr>
@@ -12693,23 +12756,23 @@
           <p:cNvPr id="36" name="S4_DeploymentBand">
             <a:extLst xmlns:a="http://schemas.openxmlformats.org/drawingml/2006/main">
               <a:ext uri="{FF2B5EF4-FFF2-40B4-BE49-F238E27FC236}">
-                <a16:creationId xmlns:a16="http://schemas.microsoft.com/office/drawing/2014/main" id="{E03C8C77-CD2D-42FE-B62A-3F0766CFB734}"/>
-              </a:ext>
-            </a:extLst>
-          </p:cNvPr>
-          <p:cNvSpPr>
-            <a:spLocks xmlns:a="http://schemas.openxmlformats.org/drawingml/2006/main" noGrp="1"/>
-          </p:cNvSpPr>
-          <p:nvPr/>
-        </p:nvSpPr>
-        <p:spPr>
-          <a:xfrm xmlns:a="http://schemas.openxmlformats.org/drawingml/2006/main">
-            <a:off x="552450" y="5181600"/>
-            <a:ext cx="11087100" cy="781050"/>
+                <a16:creationId xmlns:a16="http://schemas.microsoft.com/office/drawing/2014/main" id="{2B818790-19CC-4DEE-AFC5-940C231F20B7}"/>
+              </a:ext>
+            </a:extLst>
+          </p:cNvPr>
+          <p:cNvSpPr>
+            <a:spLocks xmlns:a="http://schemas.openxmlformats.org/drawingml/2006/main" noGrp="1"/>
+          </p:cNvSpPr>
+          <p:nvPr/>
+        </p:nvSpPr>
+        <p:spPr>
+          <a:xfrm xmlns:a="http://schemas.openxmlformats.org/drawingml/2006/main">
+            <a:off x="552450" y="5105400"/>
+            <a:ext cx="11087100" cy="914400"/>
           </a:xfrm>
           <a:prstGeom xmlns:a="http://schemas.openxmlformats.org/drawingml/2006/main" prst="roundRect">
             <a:avLst>
-              <a:gd name="adj" fmla="val 7317"/>
+              <a:gd name="adj" fmla="val 6250"/>
             </a:avLst>
           </a:prstGeom>
           <a:solidFill xmlns:a="http://schemas.openxmlformats.org/drawingml/2006/main">
@@ -12728,19 +12791,19 @@
           <p:cNvPr id="37" name="S4_DeploymentLabel">
             <a:extLst xmlns:a="http://schemas.openxmlformats.org/drawingml/2006/main">
               <a:ext uri="{FF2B5EF4-FFF2-40B4-BE49-F238E27FC236}">
-                <a16:creationId xmlns:a16="http://schemas.microsoft.com/office/drawing/2014/main" id="{0723D093-B56A-42A0-BAA2-8349FB1199ED}"/>
-              </a:ext>
-            </a:extLst>
-          </p:cNvPr>
-          <p:cNvSpPr>
-            <a:spLocks xmlns:a="http://schemas.openxmlformats.org/drawingml/2006/main" noGrp="1"/>
-          </p:cNvSpPr>
-          <p:nvPr/>
-        </p:nvSpPr>
-        <p:spPr>
-          <a:xfrm xmlns:a="http://schemas.openxmlformats.org/drawingml/2006/main">
-            <a:off x="742950" y="5334000"/>
-            <a:ext cx="2952750" cy="190500"/>
+                <a16:creationId xmlns:a16="http://schemas.microsoft.com/office/drawing/2014/main" id="{22A720A9-1653-400C-85EF-0FD7BD897CCB}"/>
+              </a:ext>
+            </a:extLst>
+          </p:cNvPr>
+          <p:cNvSpPr>
+            <a:spLocks xmlns:a="http://schemas.openxmlformats.org/drawingml/2006/main" noGrp="1"/>
+          </p:cNvSpPr>
+          <p:nvPr/>
+        </p:nvSpPr>
+        <p:spPr>
+          <a:xfrm xmlns:a="http://schemas.openxmlformats.org/drawingml/2006/main">
+            <a:off x="742950" y="5238750"/>
+            <a:ext cx="4000500" cy="190500"/>
           </a:xfrm>
           <a:prstGeom xmlns:a="http://schemas.openxmlformats.org/drawingml/2006/main" prst="rect">
             <a:avLst/>
@@ -12786,7 +12849,7 @@
                 <a:ea typeface="Segoe UI"/>
                 <a:cs typeface="Segoe UI"/>
               </a:rPr>
-              <a:t>MÔ HÌNH TRIỂN KHAI HIỆN TẠI</a:t>
+              <a:t>MÔ HÌNH HIỆN TẠI VÀ RANH GIỚI BẢO MẬT</a:t>
             </a:r>
           </a:p>
         </p:txBody>
@@ -12796,19 +12859,19 @@
           <p:cNvPr id="38" name="S4_DeploymentText">
             <a:extLst xmlns:a="http://schemas.openxmlformats.org/drawingml/2006/main">
               <a:ext uri="{FF2B5EF4-FFF2-40B4-BE49-F238E27FC236}">
-                <a16:creationId xmlns:a16="http://schemas.microsoft.com/office/drawing/2014/main" id="{5E9AD0F8-1869-48C9-9332-705AF9DE7BA6}"/>
-              </a:ext>
-            </a:extLst>
-          </p:cNvPr>
-          <p:cNvSpPr>
-            <a:spLocks xmlns:a="http://schemas.openxmlformats.org/drawingml/2006/main" noGrp="1"/>
-          </p:cNvSpPr>
-          <p:nvPr/>
-        </p:nvSpPr>
-        <p:spPr>
-          <a:xfrm xmlns:a="http://schemas.openxmlformats.org/drawingml/2006/main">
-            <a:off x="742950" y="5619750"/>
-            <a:ext cx="10706100" cy="228600"/>
+                <a16:creationId xmlns:a16="http://schemas.microsoft.com/office/drawing/2014/main" id="{FBD4E6FA-BDE9-45A7-B8A7-06150F07EE60}"/>
+              </a:ext>
+            </a:extLst>
+          </p:cNvPr>
+          <p:cNvSpPr>
+            <a:spLocks xmlns:a="http://schemas.openxmlformats.org/drawingml/2006/main" noGrp="1"/>
+          </p:cNvSpPr>
+          <p:nvPr/>
+        </p:nvSpPr>
+        <p:spPr>
+          <a:xfrm xmlns:a="http://schemas.openxmlformats.org/drawingml/2006/main">
+            <a:off x="742950" y="5486400"/>
+            <a:ext cx="10706100" cy="190500"/>
           </a:xfrm>
           <a:prstGeom xmlns:a="http://schemas.openxmlformats.org/drawingml/2006/main" prst="rect">
             <a:avLst/>
@@ -12819,12 +12882,12 @@
           </a:ln>
         </p:spPr>
         <p:txBody>
-          <a:bodyPr xmlns:a="http://schemas.openxmlformats.org/drawingml/2006/main" lIns="0" tIns="0" rIns="0" bIns="0" anchor="t">
+          <a:bodyPr xmlns:a="http://schemas.openxmlformats.org/drawingml/2006/main" lIns="0" tIns="0" rIns="0" bIns="0" anchor="ctr">
             <a:noAutofit/>
           </a:bodyPr>
           <a:lstStyle xmlns:a="http://schemas.openxmlformats.org/drawingml/2006/main">
             <a:defPPr algn="l">
-              <a:defRPr sz="1275" b="1">
+              <a:defRPr sz="1125" b="1">
                 <a:solidFill>
                   <a:srgbClr val="F4F7FB"/>
                 </a:solidFill>
@@ -12836,7 +12899,7 @@
           </a:lstStyle>
           <a:p xmlns:a="http://schemas.openxmlformats.org/drawingml/2006/main">
             <a:pPr algn="l">
-              <a:defRPr sz="1275" b="1">
+              <a:defRPr sz="1125" b="1">
                 <a:solidFill>
                   <a:srgbClr val="F4F7FB"/>
                 </a:solidFill>
@@ -12846,7 +12909,7 @@
               </a:defRPr>
             </a:pPr>
             <a:r>
-              <a:rPr sz="1275" b="1">
+              <a:rPr sz="1125" b="1">
                 <a:solidFill>
                   <a:srgbClr val="F4F7FB"/>
                 </a:solidFill>
@@ -12854,7 +12917,75 @@
                 <a:ea typeface="Segoe UI"/>
                 <a:cs typeface="Segoe UI"/>
               </a:rPr>
-              <a:t>localhost • một process • AI qua OpenRouter / Alibaba • fallback Ollama mặc định tắt</a:t>
+              <a:t>localhost • một process • OpenRouter / Alibaba • fallback Ollama tắt</a:t>
+            </a:r>
+          </a:p>
+        </p:txBody>
+      </p:sp>
+      <p:sp>
+        <p:nvSpPr>
+          <p:cNvPr id="39" name="S4_SecurityBoundaryText">
+            <a:extLst xmlns:a="http://schemas.openxmlformats.org/drawingml/2006/main">
+              <a:ext uri="{FF2B5EF4-FFF2-40B4-BE49-F238E27FC236}">
+                <a16:creationId xmlns:a16="http://schemas.microsoft.com/office/drawing/2014/main" id="{07351854-2864-42EA-9673-C67B935A1A2A}"/>
+              </a:ext>
+            </a:extLst>
+          </p:cNvPr>
+          <p:cNvSpPr>
+            <a:spLocks xmlns:a="http://schemas.openxmlformats.org/drawingml/2006/main" noGrp="1"/>
+          </p:cNvSpPr>
+          <p:nvPr/>
+        </p:nvSpPr>
+        <p:spPr>
+          <a:xfrm xmlns:a="http://schemas.openxmlformats.org/drawingml/2006/main">
+            <a:off x="742950" y="5734050"/>
+            <a:ext cx="10706100" cy="171450"/>
+          </a:xfrm>
+          <a:prstGeom xmlns:a="http://schemas.openxmlformats.org/drawingml/2006/main" prst="rect">
+            <a:avLst/>
+          </a:prstGeom>
+          <a:noFill xmlns:a="http://schemas.openxmlformats.org/drawingml/2006/main"/>
+          <a:ln xmlns:a="http://schemas.openxmlformats.org/drawingml/2006/main" w="0">
+            <a:noFill/>
+          </a:ln>
+        </p:spPr>
+        <p:txBody>
+          <a:bodyPr xmlns:a="http://schemas.openxmlformats.org/drawingml/2006/main" lIns="0" tIns="0" rIns="0" bIns="0" anchor="ctr">
+            <a:noAutofit/>
+          </a:bodyPr>
+          <a:lstStyle xmlns:a="http://schemas.openxmlformats.org/drawingml/2006/main">
+            <a:defPPr algn="l">
+              <a:defRPr sz="1050" b="1">
+                <a:solidFill>
+                  <a:srgbClr val="A6B3C4"/>
+                </a:solidFill>
+                <a:latin typeface="Segoe UI"/>
+                <a:ea typeface="Segoe UI"/>
+                <a:cs typeface="Segoe UI"/>
+              </a:defRPr>
+            </a:defPPr>
+          </a:lstStyle>
+          <a:p xmlns:a="http://schemas.openxmlformats.org/drawingml/2006/main">
+            <a:pPr algn="l">
+              <a:defRPr sz="1050" b="1">
+                <a:solidFill>
+                  <a:srgbClr val="A6B3C4"/>
+                </a:solidFill>
+                <a:latin typeface="Segoe UI"/>
+                <a:ea typeface="Segoe UI"/>
+                <a:cs typeface="Segoe UI"/>
+              </a:defRPr>
+            </a:pPr>
+            <a:r>
+              <a:rPr sz="1050" b="1">
+                <a:solidFill>
+                  <a:srgbClr val="A6B3C4"/>
+                </a:solidFill>
+                <a:latin typeface="Segoe UI"/>
+                <a:ea typeface="Segoe UI"/>
+                <a:cs typeface="Segoe UI"/>
+              </a:rPr>
+              <a:t>Identity chỉ là metadata demo • chưa production RBAC • chưa sandbox file parser</a:t>
             </a:r>
           </a:p>
         </p:txBody>
@@ -12862,7 +12993,7 @@
     </p:spTree>
     <p:extLst>
       <p:ext uri="{BB962C8B-B14F-4D97-AF65-F5344CB8AC3E}">
-        <p14:creationId xmlns:p14="http://schemas.microsoft.com/office/powerpoint/2010/main" val="1512384"/>
+        <p14:creationId xmlns:p14="http://schemas.microsoft.com/office/powerpoint/2010/main" val="47881728"/>
       </p:ext>
     </p:extLst>
   </p:cSld>
@@ -12893,7 +13024,7 @@
           <p:cNvPr id="9" name="Slide_Title">
             <a:extLst xmlns:a="http://schemas.openxmlformats.org/drawingml/2006/main">
               <a:ext uri="{FF2B5EF4-FFF2-40B4-BE49-F238E27FC236}">
-                <a16:creationId xmlns:a16="http://schemas.microsoft.com/office/drawing/2014/main" id="{624189A8-5B68-431F-8BAC-014B16E33833}"/>
+                <a16:creationId xmlns:a16="http://schemas.microsoft.com/office/drawing/2014/main" id="{0240D81A-E58A-4135-8E0E-CAD7DE8C9D38}"/>
               </a:ext>
             </a:extLst>
           </p:cNvPr>
@@ -12951,7 +13082,7 @@
                 <a:ea typeface="Segoe UI"/>
                 <a:cs typeface="Segoe UI"/>
               </a:rPr>
-              <a:t>Lỗi đã quan sát, hạn chế còn lại và hướng xử lý</a:t>
+              <a:t>Từ demo đến production: lỗi, hạn chế và security gates</a:t>
             </a:r>
           </a:p>
         </p:txBody>
@@ -12961,7 +13092,7 @@
           <p:cNvPr id="2" name="Slide_Subtitle">
             <a:extLst xmlns:a="http://schemas.openxmlformats.org/drawingml/2006/main">
               <a:ext uri="{FF2B5EF4-FFF2-40B4-BE49-F238E27FC236}">
-                <a16:creationId xmlns:a16="http://schemas.microsoft.com/office/drawing/2014/main" id="{FDB201C2-495B-4E1E-B431-71AA7636D02F}"/>
+                <a16:creationId xmlns:a16="http://schemas.microsoft.com/office/drawing/2014/main" id="{FBCBF260-38F4-4304-9ABA-86CB57172D8C}"/>
               </a:ext>
             </a:extLst>
           </p:cNvPr>
@@ -13019,7 +13150,7 @@
                 <a:ea typeface="Segoe UI"/>
                 <a:cs typeface="Segoe UI"/>
               </a:rPr>
-              <a:t>Mỗi vấn đề có nguyên nhân, phản ứng an toàn và điều kiện xác nhận trước khi mở rộng.</a:t>
+              <a:t>Identity, least privilege, sandbox và scale đều cần gate xác nhận trước pilot.</a:t>
             </a:r>
           </a:p>
         </p:txBody>
@@ -13029,7 +13160,7 @@
           <p:cNvPr id="3" name="S5_ObservedHeading">
             <a:extLst xmlns:a="http://schemas.openxmlformats.org/drawingml/2006/main">
               <a:ext uri="{FF2B5EF4-FFF2-40B4-BE49-F238E27FC236}">
-                <a16:creationId xmlns:a16="http://schemas.microsoft.com/office/drawing/2014/main" id="{9ED4F785-F584-4CFC-BC85-0C3637E97FF6}"/>
+                <a16:creationId xmlns:a16="http://schemas.microsoft.com/office/drawing/2014/main" id="{D50F04C8-C9F0-490D-8FB1-30EFE9AA743C}"/>
               </a:ext>
             </a:extLst>
           </p:cNvPr>
@@ -13097,7 +13228,7 @@
           <p:cNvPr id="4" name="S5_RoadmapHeading">
             <a:extLst xmlns:a="http://schemas.openxmlformats.org/drawingml/2006/main">
               <a:ext uri="{FF2B5EF4-FFF2-40B4-BE49-F238E27FC236}">
-                <a16:creationId xmlns:a16="http://schemas.microsoft.com/office/drawing/2014/main" id="{80279128-8207-4B9B-93F9-6193BF8A3FDB}"/>
+                <a16:creationId xmlns:a16="http://schemas.microsoft.com/office/drawing/2014/main" id="{E59CA974-F471-4EE9-9D4A-9C7A1F03DA21}"/>
               </a:ext>
             </a:extLst>
           </p:cNvPr>
@@ -13165,7 +13296,7 @@
           <p:cNvPr id="5" name="S5_ObservedErrorsTable">
             <a:extLst xmlns:a="http://schemas.openxmlformats.org/drawingml/2006/main">
               <a:ext uri="{FF2B5EF4-FFF2-40B4-BE49-F238E27FC236}">
-                <a16:creationId xmlns:a16="http://schemas.microsoft.com/office/drawing/2014/main" id="{4BD1FA37-B574-4272-976B-199F5D3CCE0F}"/>
+                <a16:creationId xmlns:a16="http://schemas.microsoft.com/office/drawing/2014/main" id="{3B33A3EB-6ADD-44ED-AB4A-8B51658AFD08}"/>
               </a:ext>
             </a:extLst>
           </p:cNvPr>
@@ -13564,7 +13695,7 @@
           <p:cNvPr id="6" name="S5_RoadmapTable">
             <a:extLst xmlns:a="http://schemas.openxmlformats.org/drawingml/2006/main">
               <a:ext uri="{FF2B5EF4-FFF2-40B4-BE49-F238E27FC236}">
-                <a16:creationId xmlns:a16="http://schemas.microsoft.com/office/drawing/2014/main" id="{003D3FC3-6346-49D2-98D6-6323D2D2E146}"/>
+                <a16:creationId xmlns:a16="http://schemas.microsoft.com/office/drawing/2014/main" id="{5598C5A7-3272-413A-BBCF-6B57A9B41836}"/>
               </a:ext>
             </a:extLst>
           </p:cNvPr>
@@ -13850,7 +13981,7 @@
                           <a:ea typeface="Segoe UI"/>
                           <a:cs typeface="Segoe UI"/>
                         </a:rPr>
-                        <a:t>PDF + object storage</a:t>
+                        <a:t>Sandbox ingestion + storage</a:t>
                       </a:r>
                     </a:p>
                   </a:txBody>
@@ -13892,7 +14023,7 @@
                           <a:ea typeface="Segoe UI"/>
                           <a:cs typeface="Segoe UI"/>
                         </a:rPr>
-                        <a:t>Thêm PDF ingestion và private object store. Gate: MIME, AV và retrieval regression đều pass.</a:t>
+                        <a:t>Quarantine; MIME + AV/CDR; parser ít quyền, giới hạn CPU/RAM/time/egress. Gate: malicious-file tests pass.</a:t>
                       </a:r>
                     </a:p>
                   </a:txBody>
@@ -13930,7 +14061,7 @@
                           <a:ea typeface="Segoe UI"/>
                           <a:cs typeface="Segoe UI"/>
                         </a:rPr>
-                        <a:t>RBAC</a:t>
+                        <a:t>Identity + least privilege</a:t>
                       </a:r>
                     </a:p>
                   </a:txBody>
@@ -13972,7 +14103,7 @@
                           <a:ea typeface="Segoe UI"/>
                           <a:cs typeface="Segoe UI"/>
                         </a:rPr>
-                        <a:t>Lập role matrix và authorization tests. Gate: thao tác sai quyền bị chặn và có audit.</a:t>
+                        <a:t>OIDC/SSO + service identity; deny-by-default role matrix. Gate: thao tác sai quyền bị chặn và có audit.</a:t>
                       </a:r>
                     </a:p>
                   </a:txBody>
@@ -14084,7 +14215,7 @@
           <p:cNvPr id="7" name="S5_PrincipleBand">
             <a:extLst xmlns:a="http://schemas.openxmlformats.org/drawingml/2006/main">
               <a:ext uri="{FF2B5EF4-FFF2-40B4-BE49-F238E27FC236}">
-                <a16:creationId xmlns:a16="http://schemas.microsoft.com/office/drawing/2014/main" id="{3CD7F064-CC91-4D2F-A8D0-E16102CB1562}"/>
+                <a16:creationId xmlns:a16="http://schemas.microsoft.com/office/drawing/2014/main" id="{4D4870CC-1DDC-49CE-836B-D9D4EB413954}"/>
               </a:ext>
             </a:extLst>
           </p:cNvPr>
@@ -14119,7 +14250,7 @@
           <p:cNvPr id="8" name="S5_PrincipleText">
             <a:extLst xmlns:a="http://schemas.openxmlformats.org/drawingml/2006/main">
               <a:ext uri="{FF2B5EF4-FFF2-40B4-BE49-F238E27FC236}">
-                <a16:creationId xmlns:a16="http://schemas.microsoft.com/office/drawing/2014/main" id="{2A2FFF7D-4A85-4133-B8AB-4405AE92485E}"/>
+                <a16:creationId xmlns:a16="http://schemas.microsoft.com/office/drawing/2014/main" id="{2F1DBC2E-82BE-407A-88CB-7AFDB0F810CF}"/>
               </a:ext>
             </a:extLst>
           </p:cNvPr>
@@ -14147,7 +14278,7 @@
           </a:bodyPr>
           <a:lstStyle xmlns:a="http://schemas.openxmlformats.org/drawingml/2006/main">
             <a:defPPr algn="ctr">
-              <a:defRPr sz="1125" b="1">
+              <a:defRPr sz="1050" b="1">
                 <a:solidFill>
                   <a:srgbClr val="F4F7FB"/>
                 </a:solidFill>
@@ -14159,7 +14290,7 @@
           </a:lstStyle>
           <a:p xmlns:a="http://schemas.openxmlformats.org/drawingml/2006/main">
             <a:pPr algn="ctr">
-              <a:defRPr sz="1125" b="1">
+              <a:defRPr sz="1050" b="1">
                 <a:solidFill>
                   <a:srgbClr val="F4F7FB"/>
                 </a:solidFill>
@@ -14169,7 +14300,7 @@
               </a:defRPr>
             </a:pPr>
             <a:r>
-              <a:rPr sz="1125" b="1">
+              <a:rPr sz="1050" b="1">
                 <a:solidFill>
                   <a:srgbClr val="F4F7FB"/>
                 </a:solidFill>
@@ -14177,7 +14308,7 @@
                 <a:ea typeface="Segoe UI"/>
                 <a:cs typeface="Segoe UI"/>
               </a:rPr>
-              <a:t>Giữ fail-safe, không tune bằng holdout; mọi cải tiến phải có fixture độc lập và gate xác nhận.</a:t>
+              <a:t>Model không có quyền thực thi; giữ fail-safe, không tune bằng holdout; chỉ mở rộng khi security gate đạt.</a:t>
             </a:r>
           </a:p>
         </p:txBody>
@@ -14185,7 +14316,7 @@
     </p:spTree>
     <p:extLst>
       <p:ext uri="{BB962C8B-B14F-4D97-AF65-F5344CB8AC3E}">
-        <p14:creationId xmlns:p14="http://schemas.microsoft.com/office/powerpoint/2010/main" val="1092959788"/>
+        <p14:creationId xmlns:p14="http://schemas.microsoft.com/office/powerpoint/2010/main" val="1740443866"/>
       </p:ext>
     </p:extLst>
   </p:cSld>

</xml_diff>